<commit_message>
Final deck with speaker notes and verification results
</commit_message>
<xml_diff>
--- a/productivity-saas/deploy/productivity-tracker-aws.pptx
+++ b/productivity-saas/deploy/productivity-tracker-aws.pptx
@@ -16,9 +16,10 @@
     <p:sldId id="264" r:id="rId10"/>
     <p:sldId id="265" r:id="rId11"/>
     <p:sldId id="266" r:id="rId12"/>
+    <p:sldId id="267" r:id="rId13"/>
   </p:sldIdLst>
   <p:notesMasterIdLst>
-    <p:notesMasterId r:id="rId13"/>
+    <p:notesMasterId r:id="rId14"/>
   </p:notesMasterIdLst>
   <p:sldSz cx="9144000" cy="5143500"/>
   <p:notesSz cx="5143500" cy="9144000"/>
@@ -117,13 +118,13 @@
   <p:extLst>
     <p:ext uri="{521415D9-36F7-43E2-AB2F-B90AF26B5E84}">
       <p14:sectionLst xmlns:p14="http://schemas.microsoft.com/office/powerpoint/2010/main">
-        <p14:section name="Intro" id="{b306df3d-1d10-ea10-878e-333eba50cb4d}">
+        <p14:section name="Intro" id="{8cbfcbd1-0268-af80-0b31-596d9d385457}">
           <p14:sldIdLst>
             <p14:sldId id="256"/>
             <p14:sldId id="257"/>
           </p14:sldIdLst>
         </p14:section>
-        <p14:section name="Deployment" id="{71420b8f-f764-3b24-bd25-f17bf69abbfd}">
+        <p14:section name="Deployment" id="{5299376f-ddff-00b4-a675-1025283312f2}">
           <p14:sldIdLst>
             <p14:sldId id="258"/>
             <p14:sldId id="259"/>
@@ -133,15 +134,16 @@
             <p14:sldId id="263"/>
           </p14:sldIdLst>
         </p14:section>
-        <p14:section name="Hardening" id="{174d8934-b2d2-00e8-8957-cf1a8b53ba54}">
+        <p14:section name="Hardening" id="{c05ffe42-dad2-d559-2461-a9b012d49126}">
           <p14:sldIdLst>
             <p14:sldId id="264"/>
             <p14:sldId id="265"/>
+            <p14:sldId id="266"/>
           </p14:sldIdLst>
         </p14:section>
-        <p14:section name="Wrap up" id="{d00a4edb-bf94-625f-9d3c-3c8504deff70}">
+        <p14:section name="Wrap up" id="{381bffe4-f689-dd2d-a10a-986953121b0a}">
           <p14:sldIdLst>
-            <p14:sldId id="266"/>
+            <p14:sldId id="267"/>
           </p14:sldIdLst>
         </p14:section>
       </p14:sectionLst>
@@ -636,7 +638,7 @@
           <a:p>
             <a:r>
               <a:rPr lang="en-US" dirty="0"/>
-              <a:t/>
+              <a:t>These are the checks run against the live server. Logged-in features were exercised in the live demo with a real account.</a:t>
             </a:r>
             <a:endParaRPr lang="en-US" dirty="0"/>
           </a:p>
@@ -724,7 +726,7 @@
           <a:p>
             <a:r>
               <a:rPr lang="en-US" dirty="0"/>
-              <a:t/>
+              <a:t>Roadmap: HTTPS through CloudFront once AWS finishes verifying the account, a domain, redundancy with a load balancer, log shipping, backups and a CI/CD pipeline.</a:t>
             </a:r>
             <a:endParaRPr lang="en-US" dirty="0"/>
           </a:p>
@@ -748,6 +750,94 @@
             <a:fld id="{F7021451-1387-4CA6-816F-3879F97B5CBC}" type="slidenum">
               <a:rPr lang="en-US"/>
               <a:t>11</a:t>
+            </a:fld>
+            <a:endParaRPr lang="en-US"/>
+          </a:p>
+        </p:txBody>
+      </p:sp>
+    </p:spTree>
+    <p:extLst>
+      <p:ext uri="{BB962C8B-B14F-4D97-AF65-F5344CB8AC3E}">
+        <p14:creationId xmlns:p14="http://schemas.microsoft.com/office/powerpoint/2010/main" val="1024086991"/>
+      </p:ext>
+    </p:extLst>
+  </p:cSld>
+  <p:clrMapOvr>
+    <a:masterClrMapping/>
+  </p:clrMapOvr>
+</p:notes>
+</file>
+
+<file path=ppt/notesSlides/notesSlide12.xml><?xml version="1.0" encoding="utf-8"?>
+<p:notes xmlns:a="http://schemas.openxmlformats.org/drawingml/2006/main" xmlns:r="http://schemas.openxmlformats.org/officeDocument/2006/relationships" xmlns:p="http://schemas.openxmlformats.org/presentationml/2006/main">
+  <p:cSld>
+    <p:spTree>
+      <p:nvGrpSpPr>
+        <p:cNvPr id="1" name=""/>
+        <p:cNvGrpSpPr/>
+        <p:nvPr/>
+      </p:nvGrpSpPr>
+      <p:grpSpPr>
+        <a:xfrm>
+          <a:off x="0" y="0"/>
+          <a:ext cx="0" cy="0"/>
+          <a:chOff x="0" y="0"/>
+          <a:chExt cx="0" cy="0"/>
+        </a:xfrm>
+      </p:grpSpPr>
+      <p:sp>
+        <p:nvSpPr>
+          <p:cNvPr id="2" name="Slide Image Placeholder 1"/>
+          <p:cNvSpPr>
+            <a:spLocks noGrp="1" noRot="1" noChangeAspect="1"/>
+          </p:cNvSpPr>
+          <p:nvPr>
+            <p:ph type="sldImg"/>
+          </p:nvPr>
+        </p:nvSpPr>
+        <p:spPr/>
+      </p:sp>
+      <p:sp>
+        <p:nvSpPr>
+          <p:cNvPr id="3" name="Notes Placeholder 2"/>
+          <p:cNvSpPr>
+            <a:spLocks noGrp="1"/>
+          </p:cNvSpPr>
+          <p:nvPr>
+            <p:ph type="body" idx="1"/>
+          </p:nvPr>
+        </p:nvSpPr>
+        <p:spPr/>
+        <p:txBody>
+          <a:bodyPr/>
+          <a:lstStyle/>
+          <a:p>
+            <a:r>
+              <a:rPr lang="en-US" dirty="0"/>
+              <a:t>Close: the site is live at the address on screen. Everything is reproducible from the repository. Happy to take questions or demo.</a:t>
+            </a:r>
+            <a:endParaRPr lang="en-US" dirty="0"/>
+          </a:p>
+        </p:txBody>
+      </p:sp>
+      <p:sp>
+        <p:nvSpPr>
+          <p:cNvPr id="4" name="Slide Number Placeholder 3"/>
+          <p:cNvSpPr>
+            <a:spLocks noGrp="1"/>
+          </p:cNvSpPr>
+          <p:nvPr>
+            <p:ph type="sldNum" sz="quarter" idx="10"/>
+          </p:nvPr>
+        </p:nvSpPr>
+        <p:spPr/>
+        <p:txBody>
+          <a:bodyPr/>
+          <a:lstStyle/>
+          <a:p>
+            <a:fld id="{F7021451-1387-4CA6-816F-3879F97B5CBC}" type="slidenum">
+              <a:rPr lang="en-US"/>
+              <a:t>12</a:t>
             </a:fld>
             <a:endParaRPr lang="en-US"/>
           </a:p>
@@ -812,7 +902,7 @@
           <a:p>
             <a:r>
               <a:rPr lang="en-US" dirty="0"/>
-              <a:t/>
+              <a:t>Explain the app first: it is a personal productivity platform. Tasks and habits with streaks, Pomodoro focus sessions with automatic distraction detection, notes, a calendar and an analytics dashboard with two custom scores. Stack is vanilla JS, Node and Express, JWT with bcrypt, MongoDB Atlas.</a:t>
             </a:r>
             <a:endParaRPr lang="en-US" dirty="0"/>
           </a:p>
@@ -900,7 +990,7 @@
           <a:p>
             <a:r>
               <a:rPr lang="en-US" dirty="0"/>
-              <a:t/>
+              <a:t>Before this the app ran on Netlify and Render free tiers, where the API sleeps and the first load is slow. The goal of the project was to move it to AWS so everything is always on and defined as code.</a:t>
             </a:r>
             <a:endParaRPr lang="en-US" dirty="0"/>
           </a:p>
@@ -988,7 +1078,7 @@
           <a:p>
             <a:r>
               <a:rPr lang="en-US" dirty="0"/>
-              <a:t>Browser hits the Elastic IP on port 80. nginx serves the client and proxies /api to Node. Node reads secrets from SSM through the instance role and talks to Atlas.</a:t>
+              <a:t>Browser hits the Elastic IP on port 80. nginx serves the client and proxies /api to Node. Node reads secrets from SSM through the instance role and talks to Atlas.Table of every AWS service used and its job. Stress that nothing is clicked together by hand: CloudFormation builds all of it from one file.</a:t>
             </a:r>
             <a:endParaRPr lang="en-US" dirty="0"/>
           </a:p>
@@ -1252,7 +1342,7 @@
           <a:p>
             <a:r>
               <a:rPr lang="en-US" dirty="0"/>
-              <a:t/>
+              <a:t>Secrets flow. They are stored encrypted in Parameter Store, fetched at service start through the instance role, written to memory only, and rotated by updating the parameter and restarting.</a:t>
             </a:r>
             <a:endParaRPr lang="en-US" dirty="0"/>
           </a:p>
@@ -1340,7 +1430,7 @@
           <a:p>
             <a:r>
               <a:rPr lang="en-US" dirty="0"/>
-              <a:t/>
+              <a:t>Real problems we hit. The last one is the best story: logins timed out and it looked like an Atlas firewall problem, but the server log showed it was connecting to localhost. The shell reading the env file treated the ampersands in the connection string as syntax. Reading the log instead of guessing found it in minutes.</a:t>
             </a:r>
             <a:endParaRPr lang="en-US" dirty="0"/>
           </a:p>
@@ -2261,834 +2351,910 @@
                   <a:schemeClr val="tx2"/>
                 </a:solidFill>
               </a:rPr>
-              <a:t>What comes next</a:t>
+              <a:t>How it was verified</a:t>
             </a:r>
             <a:endParaRPr lang="en-US" sz="3000" dirty="0"/>
           </a:p>
         </p:txBody>
       </p:sp>
-      <p:sp>
-        <p:nvSpPr>
-          <p:cNvPr id="3" name="rm0"/>
-          <p:cNvSpPr/>
-          <p:nvPr/>
-        </p:nvSpPr>
-        <p:spPr>
-          <a:xfrm>
-            <a:off x="548640" y="1280160"/>
-            <a:ext cx="2560320" cy="1554480"/>
-          </a:xfrm>
-          <a:prstGeom prst="roundRect">
-            <a:avLst>
-              <a:gd name="adj" fmla="val 4706"/>
-            </a:avLst>
-          </a:prstGeom>
-          <a:solidFill>
-            <a:schemeClr val="bg2"/>
-          </a:solidFill>
-          <a:ln w="6350">
-            <a:solidFill>
-              <a:schemeClr val="bg2"/>
-            </a:solidFill>
-            <a:prstDash val="solid"/>
-          </a:ln>
-        </p:spPr>
-      </p:sp>
-      <p:sp>
-        <p:nvSpPr>
-          <p:cNvPr id="4" name="rn0"/>
-          <p:cNvSpPr txBox="1"/>
-          <p:nvPr/>
-        </p:nvSpPr>
-        <p:spPr>
-          <a:xfrm>
-            <a:off x="685800" y="1417320"/>
-            <a:ext cx="384048" cy="384048"/>
-          </a:xfrm>
-          <a:prstGeom prst="ellipse">
-            <a:avLst/>
-          </a:prstGeom>
-          <a:solidFill>
-            <a:schemeClr val="accent2"/>
-          </a:solidFill>
-          <a:ln/>
-        </p:spPr>
-        <p:txBody>
-          <a:bodyPr wrap="square" lIns="0" tIns="0" rIns="0" bIns="0" rtlCol="0" anchor="ctr"/>
-          <a:lstStyle/>
-          <a:p>
-            <a:pPr algn="ctr" indent="0" marL="0">
-              <a:buNone/>
-            </a:pPr>
-            <a:r>
-              <a:rPr lang="en-US" sz="1400" b="1" dirty="0">
-                <a:solidFill>
-                  <a:schemeClr val="bg1"/>
-                </a:solidFill>
-              </a:rPr>
-              <a:t>1</a:t>
-            </a:r>
-            <a:endParaRPr lang="en-US" sz="1400" dirty="0"/>
-          </a:p>
-        </p:txBody>
-      </p:sp>
-      <p:sp>
-        <p:nvSpPr>
-          <p:cNvPr id="5" name="Text 3"/>
-          <p:cNvSpPr txBox="1"/>
-          <p:nvPr/>
-        </p:nvSpPr>
-        <p:spPr>
-          <a:xfrm>
-            <a:off x="1143000" y="1417320"/>
-            <a:ext cx="1874520" cy="384048"/>
-          </a:xfrm>
-          <a:prstGeom prst="rect">
-            <a:avLst/>
-          </a:prstGeom>
-          <a:noFill/>
-          <a:ln/>
-        </p:spPr>
-        <p:txBody>
-          <a:bodyPr wrap="square" lIns="0" tIns="0" rIns="0" bIns="0" rtlCol="0" anchor="ctr"/>
-          <a:lstStyle/>
-          <a:p>
-            <a:pPr indent="0" marL="0">
-              <a:buNone/>
-            </a:pPr>
-            <a:r>
-              <a:rPr lang="en-US" sz="1600" b="1" dirty="0">
-                <a:solidFill>
-                  <a:schemeClr val="tx2"/>
-                </a:solidFill>
-              </a:rPr>
-              <a:t>HTTPS</a:t>
-            </a:r>
-            <a:endParaRPr lang="en-US" sz="1600" dirty="0"/>
-          </a:p>
-        </p:txBody>
-      </p:sp>
-      <p:sp>
-        <p:nvSpPr>
-          <p:cNvPr id="6" name="Text 4"/>
-          <p:cNvSpPr txBox="1"/>
-          <p:nvPr/>
-        </p:nvSpPr>
-        <p:spPr>
-          <a:xfrm>
-            <a:off x="685800" y="1901952"/>
-            <a:ext cx="2286000" cy="868680"/>
-          </a:xfrm>
-          <a:prstGeom prst="rect">
-            <a:avLst/>
-          </a:prstGeom>
-          <a:noFill/>
-          <a:ln/>
-        </p:spPr>
-        <p:txBody>
-          <a:bodyPr wrap="square" lIns="0" tIns="0" rIns="0" bIns="0" rtlCol="0" anchor="t"/>
-          <a:lstStyle/>
-          <a:p>
-            <a:pPr indent="0" marL="0">
-              <a:buNone/>
-            </a:pPr>
-            <a:r>
-              <a:rPr lang="en-US" sz="1400" dirty="0">
-                <a:solidFill>
-                  <a:schemeClr val="tx1"/>
-                </a:solidFill>
-              </a:rPr>
-              <a:t>CloudFront and an ACM certificate once verification clears</a:t>
-            </a:r>
-            <a:endParaRPr lang="en-US" sz="1400" dirty="0"/>
-          </a:p>
-        </p:txBody>
-      </p:sp>
-      <p:sp>
-        <p:nvSpPr>
-          <p:cNvPr id="7" name="rm1"/>
-          <p:cNvSpPr/>
-          <p:nvPr/>
-        </p:nvSpPr>
-        <p:spPr>
-          <a:xfrm>
-            <a:off x="3291840" y="1280160"/>
-            <a:ext cx="2560320" cy="1554480"/>
-          </a:xfrm>
-          <a:prstGeom prst="roundRect">
-            <a:avLst>
-              <a:gd name="adj" fmla="val 4706"/>
-            </a:avLst>
-          </a:prstGeom>
-          <a:solidFill>
-            <a:schemeClr val="bg2"/>
-          </a:solidFill>
-          <a:ln w="6350">
-            <a:solidFill>
-              <a:schemeClr val="bg2"/>
-            </a:solidFill>
-            <a:prstDash val="solid"/>
-          </a:ln>
-        </p:spPr>
-      </p:sp>
-      <p:sp>
-        <p:nvSpPr>
-          <p:cNvPr id="8" name="rn1"/>
-          <p:cNvSpPr txBox="1"/>
-          <p:nvPr/>
-        </p:nvSpPr>
-        <p:spPr>
-          <a:xfrm>
-            <a:off x="3429000" y="1417320"/>
-            <a:ext cx="384048" cy="384048"/>
-          </a:xfrm>
-          <a:prstGeom prst="ellipse">
-            <a:avLst/>
-          </a:prstGeom>
-          <a:solidFill>
-            <a:schemeClr val="accent2"/>
-          </a:solidFill>
-          <a:ln/>
-        </p:spPr>
-        <p:txBody>
-          <a:bodyPr wrap="square" lIns="0" tIns="0" rIns="0" bIns="0" rtlCol="0" anchor="ctr"/>
-          <a:lstStyle/>
-          <a:p>
-            <a:pPr algn="ctr" indent="0" marL="0">
-              <a:buNone/>
-            </a:pPr>
-            <a:r>
-              <a:rPr lang="en-US" sz="1400" b="1" dirty="0">
-                <a:solidFill>
-                  <a:schemeClr val="bg1"/>
-                </a:solidFill>
-              </a:rPr>
-              <a:t>2</a:t>
-            </a:r>
-            <a:endParaRPr lang="en-US" sz="1400" dirty="0"/>
-          </a:p>
-        </p:txBody>
-      </p:sp>
-      <p:sp>
-        <p:nvSpPr>
-          <p:cNvPr id="9" name="Text 7"/>
-          <p:cNvSpPr txBox="1"/>
-          <p:nvPr/>
-        </p:nvSpPr>
-        <p:spPr>
-          <a:xfrm>
-            <a:off x="3886200" y="1417320"/>
-            <a:ext cx="1874520" cy="384048"/>
-          </a:xfrm>
-          <a:prstGeom prst="rect">
-            <a:avLst/>
-          </a:prstGeom>
-          <a:noFill/>
-          <a:ln/>
-        </p:spPr>
-        <p:txBody>
-          <a:bodyPr wrap="square" lIns="0" tIns="0" rIns="0" bIns="0" rtlCol="0" anchor="ctr"/>
-          <a:lstStyle/>
-          <a:p>
-            <a:pPr indent="0" marL="0">
-              <a:buNone/>
-            </a:pPr>
-            <a:r>
-              <a:rPr lang="en-US" sz="1600" b="1" dirty="0">
-                <a:solidFill>
-                  <a:schemeClr val="tx2"/>
-                </a:solidFill>
-              </a:rPr>
-              <a:t>Custom domain</a:t>
-            </a:r>
-            <a:endParaRPr lang="en-US" sz="1600" dirty="0"/>
-          </a:p>
-        </p:txBody>
-      </p:sp>
-      <p:sp>
-        <p:nvSpPr>
-          <p:cNvPr id="10" name="Text 8"/>
-          <p:cNvSpPr txBox="1"/>
-          <p:nvPr/>
-        </p:nvSpPr>
-        <p:spPr>
-          <a:xfrm>
-            <a:off x="3429000" y="1901952"/>
-            <a:ext cx="2286000" cy="868680"/>
-          </a:xfrm>
-          <a:prstGeom prst="rect">
-            <a:avLst/>
-          </a:prstGeom>
-          <a:noFill/>
-          <a:ln/>
-        </p:spPr>
-        <p:txBody>
-          <a:bodyPr wrap="square" lIns="0" tIns="0" rIns="0" bIns="0" rtlCol="0" anchor="t"/>
-          <a:lstStyle/>
-          <a:p>
-            <a:pPr indent="0" marL="0">
-              <a:buNone/>
-            </a:pPr>
-            <a:r>
-              <a:rPr lang="en-US" sz="1400" dirty="0">
-                <a:solidFill>
-                  <a:schemeClr val="tx1"/>
-                </a:solidFill>
-              </a:rPr>
-              <a:t>Route 53 record for a friendly name</a:t>
-            </a:r>
-            <a:endParaRPr lang="en-US" sz="1400" dirty="0"/>
-          </a:p>
-        </p:txBody>
-      </p:sp>
-      <p:sp>
-        <p:nvSpPr>
-          <p:cNvPr id="11" name="rm2"/>
-          <p:cNvSpPr/>
-          <p:nvPr/>
-        </p:nvSpPr>
-        <p:spPr>
-          <a:xfrm>
-            <a:off x="6035040" y="1280160"/>
-            <a:ext cx="2560320" cy="1554480"/>
-          </a:xfrm>
-          <a:prstGeom prst="roundRect">
-            <a:avLst>
-              <a:gd name="adj" fmla="val 4706"/>
-            </a:avLst>
-          </a:prstGeom>
-          <a:solidFill>
-            <a:schemeClr val="bg2"/>
-          </a:solidFill>
-          <a:ln w="6350">
-            <a:solidFill>
-              <a:schemeClr val="bg2"/>
-            </a:solidFill>
-            <a:prstDash val="solid"/>
-          </a:ln>
-        </p:spPr>
-      </p:sp>
-      <p:sp>
-        <p:nvSpPr>
-          <p:cNvPr id="12" name="rn2"/>
-          <p:cNvSpPr txBox="1"/>
-          <p:nvPr/>
-        </p:nvSpPr>
-        <p:spPr>
-          <a:xfrm>
-            <a:off x="6172200" y="1417320"/>
-            <a:ext cx="384048" cy="384048"/>
-          </a:xfrm>
-          <a:prstGeom prst="ellipse">
-            <a:avLst/>
-          </a:prstGeom>
-          <a:solidFill>
-            <a:schemeClr val="accent2"/>
-          </a:solidFill>
-          <a:ln/>
-        </p:spPr>
-        <p:txBody>
-          <a:bodyPr wrap="square" lIns="0" tIns="0" rIns="0" bIns="0" rtlCol="0" anchor="ctr"/>
-          <a:lstStyle/>
-          <a:p>
-            <a:pPr algn="ctr" indent="0" marL="0">
-              <a:buNone/>
-            </a:pPr>
-            <a:r>
-              <a:rPr lang="en-US" sz="1400" b="1" dirty="0">
-                <a:solidFill>
-                  <a:schemeClr val="bg1"/>
-                </a:solidFill>
-              </a:rPr>
-              <a:t>3</a:t>
-            </a:r>
-            <a:endParaRPr lang="en-US" sz="1400" dirty="0"/>
-          </a:p>
-        </p:txBody>
-      </p:sp>
-      <p:sp>
-        <p:nvSpPr>
-          <p:cNvPr id="13" name="Text 11"/>
-          <p:cNvSpPr txBox="1"/>
-          <p:nvPr/>
-        </p:nvSpPr>
-        <p:spPr>
-          <a:xfrm>
-            <a:off x="6629400" y="1417320"/>
-            <a:ext cx="1874520" cy="384048"/>
-          </a:xfrm>
-          <a:prstGeom prst="rect">
-            <a:avLst/>
-          </a:prstGeom>
-          <a:noFill/>
-          <a:ln/>
-        </p:spPr>
-        <p:txBody>
-          <a:bodyPr wrap="square" lIns="0" tIns="0" rIns="0" bIns="0" rtlCol="0" anchor="ctr"/>
-          <a:lstStyle/>
-          <a:p>
-            <a:pPr indent="0" marL="0">
-              <a:buNone/>
-            </a:pPr>
-            <a:r>
-              <a:rPr lang="en-US" sz="1600" b="1" dirty="0">
-                <a:solidFill>
-                  <a:schemeClr val="tx2"/>
-                </a:solidFill>
-              </a:rPr>
-              <a:t>High availability</a:t>
-            </a:r>
-            <a:endParaRPr lang="en-US" sz="1600" dirty="0"/>
-          </a:p>
-        </p:txBody>
-      </p:sp>
-      <p:sp>
-        <p:nvSpPr>
-          <p:cNvPr id="14" name="Text 12"/>
-          <p:cNvSpPr txBox="1"/>
-          <p:nvPr/>
-        </p:nvSpPr>
-        <p:spPr>
-          <a:xfrm>
-            <a:off x="6172200" y="1901952"/>
-            <a:ext cx="2286000" cy="868680"/>
-          </a:xfrm>
-          <a:prstGeom prst="rect">
-            <a:avLst/>
-          </a:prstGeom>
-          <a:noFill/>
-          <a:ln/>
-        </p:spPr>
-        <p:txBody>
-          <a:bodyPr wrap="square" lIns="0" tIns="0" rIns="0" bIns="0" rtlCol="0" anchor="t"/>
-          <a:lstStyle/>
-          <a:p>
-            <a:pPr indent="0" marL="0">
-              <a:buNone/>
-            </a:pPr>
-            <a:r>
-              <a:rPr lang="en-US" sz="1400" dirty="0">
-                <a:solidFill>
-                  <a:schemeClr val="tx1"/>
-                </a:solidFill>
-              </a:rPr>
-              <a:t>Load balancer and auto scaling over two zones</a:t>
-            </a:r>
-            <a:endParaRPr lang="en-US" sz="1400" dirty="0"/>
-          </a:p>
-        </p:txBody>
-      </p:sp>
-      <p:sp>
-        <p:nvSpPr>
-          <p:cNvPr id="15" name="rm3"/>
-          <p:cNvSpPr/>
-          <p:nvPr/>
-        </p:nvSpPr>
-        <p:spPr>
-          <a:xfrm>
-            <a:off x="548640" y="3017520"/>
-            <a:ext cx="2560320" cy="1554480"/>
-          </a:xfrm>
-          <a:prstGeom prst="roundRect">
-            <a:avLst>
-              <a:gd name="adj" fmla="val 4706"/>
-            </a:avLst>
-          </a:prstGeom>
-          <a:solidFill>
-            <a:schemeClr val="bg2"/>
-          </a:solidFill>
-          <a:ln w="6350">
-            <a:solidFill>
-              <a:schemeClr val="bg2"/>
-            </a:solidFill>
-            <a:prstDash val="solid"/>
-          </a:ln>
-        </p:spPr>
-      </p:sp>
-      <p:sp>
-        <p:nvSpPr>
-          <p:cNvPr id="16" name="rn3"/>
-          <p:cNvSpPr txBox="1"/>
-          <p:nvPr/>
-        </p:nvSpPr>
-        <p:spPr>
-          <a:xfrm>
-            <a:off x="685800" y="3154680"/>
-            <a:ext cx="384048" cy="384048"/>
-          </a:xfrm>
-          <a:prstGeom prst="ellipse">
-            <a:avLst/>
-          </a:prstGeom>
-          <a:solidFill>
-            <a:schemeClr val="accent2"/>
-          </a:solidFill>
-          <a:ln/>
-        </p:spPr>
-        <p:txBody>
-          <a:bodyPr wrap="square" lIns="0" tIns="0" rIns="0" bIns="0" rtlCol="0" anchor="ctr"/>
-          <a:lstStyle/>
-          <a:p>
-            <a:pPr algn="ctr" indent="0" marL="0">
-              <a:buNone/>
-            </a:pPr>
-            <a:r>
-              <a:rPr lang="en-US" sz="1400" b="1" dirty="0">
-                <a:solidFill>
-                  <a:schemeClr val="bg1"/>
-                </a:solidFill>
-              </a:rPr>
-              <a:t>4</a:t>
-            </a:r>
-            <a:endParaRPr lang="en-US" sz="1400" dirty="0"/>
-          </a:p>
-        </p:txBody>
-      </p:sp>
-      <p:sp>
-        <p:nvSpPr>
-          <p:cNvPr id="17" name="Text 15"/>
-          <p:cNvSpPr txBox="1"/>
-          <p:nvPr/>
-        </p:nvSpPr>
-        <p:spPr>
-          <a:xfrm>
-            <a:off x="1143000" y="3154680"/>
-            <a:ext cx="1874520" cy="384048"/>
-          </a:xfrm>
-          <a:prstGeom prst="rect">
-            <a:avLst/>
-          </a:prstGeom>
-          <a:noFill/>
-          <a:ln/>
-        </p:spPr>
-        <p:txBody>
-          <a:bodyPr wrap="square" lIns="0" tIns="0" rIns="0" bIns="0" rtlCol="0" anchor="ctr"/>
-          <a:lstStyle/>
-          <a:p>
-            <a:pPr indent="0" marL="0">
-              <a:buNone/>
-            </a:pPr>
-            <a:r>
-              <a:rPr lang="en-US" sz="1600" b="1" dirty="0">
-                <a:solidFill>
-                  <a:schemeClr val="tx2"/>
-                </a:solidFill>
-              </a:rPr>
-              <a:t>Logs</a:t>
-            </a:r>
-            <a:endParaRPr lang="en-US" sz="1600" dirty="0"/>
-          </a:p>
-        </p:txBody>
-      </p:sp>
-      <p:sp>
-        <p:nvSpPr>
-          <p:cNvPr id="18" name="Text 16"/>
-          <p:cNvSpPr txBox="1"/>
-          <p:nvPr/>
-        </p:nvSpPr>
-        <p:spPr>
-          <a:xfrm>
-            <a:off x="685800" y="3639312"/>
-            <a:ext cx="2286000" cy="868680"/>
-          </a:xfrm>
-          <a:prstGeom prst="rect">
-            <a:avLst/>
-          </a:prstGeom>
-          <a:noFill/>
-          <a:ln/>
-        </p:spPr>
-        <p:txBody>
-          <a:bodyPr wrap="square" lIns="0" tIns="0" rIns="0" bIns="0" rtlCol="0" anchor="t"/>
-          <a:lstStyle/>
-          <a:p>
-            <a:pPr indent="0" marL="0">
-              <a:buNone/>
-            </a:pPr>
-            <a:r>
-              <a:rPr lang="en-US" sz="1400" dirty="0">
-                <a:solidFill>
-                  <a:schemeClr val="tx1"/>
-                </a:solidFill>
-              </a:rPr>
-              <a:t>CloudWatch agent for nginx and API logs</a:t>
-            </a:r>
-            <a:endParaRPr lang="en-US" sz="1400" dirty="0"/>
-          </a:p>
-        </p:txBody>
-      </p:sp>
-      <p:sp>
-        <p:nvSpPr>
-          <p:cNvPr id="19" name="rm4"/>
-          <p:cNvSpPr/>
-          <p:nvPr/>
-        </p:nvSpPr>
-        <p:spPr>
-          <a:xfrm>
-            <a:off x="3291840" y="3017520"/>
-            <a:ext cx="2560320" cy="1554480"/>
-          </a:xfrm>
-          <a:prstGeom prst="roundRect">
-            <a:avLst>
-              <a:gd name="adj" fmla="val 4706"/>
-            </a:avLst>
-          </a:prstGeom>
-          <a:solidFill>
-            <a:schemeClr val="bg2"/>
-          </a:solidFill>
-          <a:ln w="6350">
-            <a:solidFill>
-              <a:schemeClr val="bg2"/>
-            </a:solidFill>
-            <a:prstDash val="solid"/>
-          </a:ln>
-        </p:spPr>
-      </p:sp>
-      <p:sp>
-        <p:nvSpPr>
-          <p:cNvPr id="20" name="rn4"/>
-          <p:cNvSpPr txBox="1"/>
-          <p:nvPr/>
-        </p:nvSpPr>
-        <p:spPr>
-          <a:xfrm>
-            <a:off x="3429000" y="3154680"/>
-            <a:ext cx="384048" cy="384048"/>
-          </a:xfrm>
-          <a:prstGeom prst="ellipse">
-            <a:avLst/>
-          </a:prstGeom>
-          <a:solidFill>
-            <a:schemeClr val="accent2"/>
-          </a:solidFill>
-          <a:ln/>
-        </p:spPr>
-        <p:txBody>
-          <a:bodyPr wrap="square" lIns="0" tIns="0" rIns="0" bIns="0" rtlCol="0" anchor="ctr"/>
-          <a:lstStyle/>
-          <a:p>
-            <a:pPr algn="ctr" indent="0" marL="0">
-              <a:buNone/>
-            </a:pPr>
-            <a:r>
-              <a:rPr lang="en-US" sz="1400" b="1" dirty="0">
-                <a:solidFill>
-                  <a:schemeClr val="bg1"/>
-                </a:solidFill>
-              </a:rPr>
-              <a:t>5</a:t>
-            </a:r>
-            <a:endParaRPr lang="en-US" sz="1400" dirty="0"/>
-          </a:p>
-        </p:txBody>
-      </p:sp>
-      <p:sp>
-        <p:nvSpPr>
-          <p:cNvPr id="21" name="Text 19"/>
-          <p:cNvSpPr txBox="1"/>
-          <p:nvPr/>
-        </p:nvSpPr>
-        <p:spPr>
-          <a:xfrm>
-            <a:off x="3886200" y="3154680"/>
-            <a:ext cx="1874520" cy="384048"/>
-          </a:xfrm>
-          <a:prstGeom prst="rect">
-            <a:avLst/>
-          </a:prstGeom>
-          <a:noFill/>
-          <a:ln/>
-        </p:spPr>
-        <p:txBody>
-          <a:bodyPr wrap="square" lIns="0" tIns="0" rIns="0" bIns="0" rtlCol="0" anchor="ctr"/>
-          <a:lstStyle/>
-          <a:p>
-            <a:pPr indent="0" marL="0">
-              <a:buNone/>
-            </a:pPr>
-            <a:r>
-              <a:rPr lang="en-US" sz="1600" b="1" dirty="0">
-                <a:solidFill>
-                  <a:schemeClr val="tx2"/>
-                </a:solidFill>
-              </a:rPr>
-              <a:t>Backups</a:t>
-            </a:r>
-            <a:endParaRPr lang="en-US" sz="1600" dirty="0"/>
-          </a:p>
-        </p:txBody>
-      </p:sp>
-      <p:sp>
-        <p:nvSpPr>
-          <p:cNvPr id="22" name="Text 20"/>
-          <p:cNvSpPr txBox="1"/>
-          <p:nvPr/>
-        </p:nvSpPr>
-        <p:spPr>
-          <a:xfrm>
-            <a:off x="3429000" y="3639312"/>
-            <a:ext cx="2286000" cy="868680"/>
-          </a:xfrm>
-          <a:prstGeom prst="rect">
-            <a:avLst/>
-          </a:prstGeom>
-          <a:noFill/>
-          <a:ln/>
-        </p:spPr>
-        <p:txBody>
-          <a:bodyPr wrap="square" lIns="0" tIns="0" rIns="0" bIns="0" rtlCol="0" anchor="t"/>
-          <a:lstStyle/>
-          <a:p>
-            <a:pPr indent="0" marL="0">
-              <a:buNone/>
-            </a:pPr>
-            <a:r>
-              <a:rPr lang="en-US" sz="1400" dirty="0">
-                <a:solidFill>
-                  <a:schemeClr val="tx1"/>
-                </a:solidFill>
-              </a:rPr>
-              <a:t>Encrypted volume and AWS Backup snapshots</a:t>
-            </a:r>
-            <a:endParaRPr lang="en-US" sz="1400" dirty="0"/>
-          </a:p>
-        </p:txBody>
-      </p:sp>
-      <p:sp>
-        <p:nvSpPr>
-          <p:cNvPr id="23" name="rm5"/>
-          <p:cNvSpPr/>
-          <p:nvPr/>
-        </p:nvSpPr>
-        <p:spPr>
-          <a:xfrm>
-            <a:off x="6035040" y="3017520"/>
-            <a:ext cx="2560320" cy="1554480"/>
-          </a:xfrm>
-          <a:prstGeom prst="roundRect">
-            <a:avLst>
-              <a:gd name="adj" fmla="val 4706"/>
-            </a:avLst>
-          </a:prstGeom>
-          <a:solidFill>
-            <a:schemeClr val="bg2"/>
-          </a:solidFill>
-          <a:ln w="6350">
-            <a:solidFill>
-              <a:schemeClr val="bg2"/>
-            </a:solidFill>
-            <a:prstDash val="solid"/>
-          </a:ln>
-        </p:spPr>
-      </p:sp>
-      <p:sp>
-        <p:nvSpPr>
-          <p:cNvPr id="24" name="rn5"/>
-          <p:cNvSpPr txBox="1"/>
-          <p:nvPr/>
-        </p:nvSpPr>
-        <p:spPr>
-          <a:xfrm>
-            <a:off x="6172200" y="3154680"/>
-            <a:ext cx="384048" cy="384048"/>
-          </a:xfrm>
-          <a:prstGeom prst="ellipse">
-            <a:avLst/>
-          </a:prstGeom>
-          <a:solidFill>
-            <a:schemeClr val="accent2"/>
-          </a:solidFill>
-          <a:ln/>
-        </p:spPr>
-        <p:txBody>
-          <a:bodyPr wrap="square" lIns="0" tIns="0" rIns="0" bIns="0" rtlCol="0" anchor="ctr"/>
-          <a:lstStyle/>
-          <a:p>
-            <a:pPr algn="ctr" indent="0" marL="0">
-              <a:buNone/>
-            </a:pPr>
-            <a:r>
-              <a:rPr lang="en-US" sz="1400" b="1" dirty="0">
-                <a:solidFill>
-                  <a:schemeClr val="bg1"/>
-                </a:solidFill>
-              </a:rPr>
-              <a:t>6</a:t>
-            </a:r>
-            <a:endParaRPr lang="en-US" sz="1400" dirty="0"/>
-          </a:p>
-        </p:txBody>
-      </p:sp>
-      <p:sp>
-        <p:nvSpPr>
-          <p:cNvPr id="25" name="Text 23"/>
-          <p:cNvSpPr txBox="1"/>
-          <p:nvPr/>
-        </p:nvSpPr>
-        <p:spPr>
-          <a:xfrm>
-            <a:off x="6629400" y="3154680"/>
-            <a:ext cx="1874520" cy="384048"/>
-          </a:xfrm>
-          <a:prstGeom prst="rect">
-            <a:avLst/>
-          </a:prstGeom>
-          <a:noFill/>
-          <a:ln/>
-        </p:spPr>
-        <p:txBody>
-          <a:bodyPr wrap="square" lIns="0" tIns="0" rIns="0" bIns="0" rtlCol="0" anchor="ctr"/>
-          <a:lstStyle/>
-          <a:p>
-            <a:pPr indent="0" marL="0">
-              <a:buNone/>
-            </a:pPr>
-            <a:r>
-              <a:rPr lang="en-US" sz="1600" b="1" dirty="0">
-                <a:solidFill>
-                  <a:schemeClr val="tx2"/>
-                </a:solidFill>
-              </a:rPr>
-              <a:t>CI/CD</a:t>
-            </a:r>
-            <a:endParaRPr lang="en-US" sz="1600" dirty="0"/>
-          </a:p>
-        </p:txBody>
-      </p:sp>
-      <p:sp>
-        <p:nvSpPr>
-          <p:cNvPr id="26" name="Text 24"/>
-          <p:cNvSpPr txBox="1"/>
-          <p:nvPr/>
-        </p:nvSpPr>
-        <p:spPr>
-          <a:xfrm>
-            <a:off x="6172200" y="3639312"/>
-            <a:ext cx="2286000" cy="868680"/>
-          </a:xfrm>
-          <a:prstGeom prst="rect">
-            <a:avLst/>
-          </a:prstGeom>
-          <a:noFill/>
-          <a:ln/>
-        </p:spPr>
-        <p:txBody>
-          <a:bodyPr wrap="square" lIns="0" tIns="0" rIns="0" bIns="0" rtlCol="0" anchor="t"/>
-          <a:lstStyle/>
-          <a:p>
-            <a:pPr indent="0" marL="0">
-              <a:buNone/>
-            </a:pPr>
-            <a:r>
-              <a:rPr lang="en-US" sz="1400" dirty="0">
-                <a:solidFill>
-                  <a:schemeClr val="tx1"/>
-                </a:solidFill>
-              </a:rPr>
-              <a:t>GitHub Actions updates the stack on push</a:t>
-            </a:r>
-            <a:endParaRPr lang="en-US" sz="1400" dirty="0"/>
-          </a:p>
-        </p:txBody>
-      </p:sp>
+      <p:graphicFrame>
+        <p:nvGraphicFramePr>
+          <p:cNvPr id="11" name="Table 0"/>
+          <p:cNvGraphicFramePr>
+            <a:graphicFrameLocks noGrp="1"/>
+          </p:cNvGraphicFramePr>
+          <p:nvPr>
+            <p:extLst>
+              <p:ext uri="{D42A27DB-BD31-4B8C-83A1-F6EECF244321}">
+                <p14:modId xmlns:p14="http://schemas.microsoft.com/office/powerpoint/2010/main" val="1579011935"/>
+              </p:ext>
+            </p:extLst>
+          </p:nvPr>
+        </p:nvGraphicFramePr>
+        <p:xfrm>
+          <a:off x="548640" y="1234440"/>
+          <a:ext cx="8046720" cy="914400"/>
+        </p:xfrm>
+        <a:graphic>
+          <a:graphicData uri="http://schemas.openxmlformats.org/drawingml/2006/table">
+            <a:tbl>
+              <a:tblPr/>
+              <a:tblGrid>
+                <a:gridCol w="3291840"/>
+                <a:gridCol w="4754880"/>
+              </a:tblGrid>
+              <a:tr h="457200">
+                <a:tc>
+                  <a:txBody>
+                    <a:bodyPr/>
+                    <a:lstStyle/>
+                    <a:p>
+                      <a:pPr indent="0" marL="0">
+                        <a:buNone/>
+                      </a:pPr>
+                      <a:r>
+                        <a:rPr lang="en-US" sz="1400" b="1" dirty="0">
+                          <a:solidFill>
+                            <a:schemeClr val="bg1"/>
+                          </a:solidFill>
+                        </a:rPr>
+                        <a:t>Check</a:t>
+                      </a:r>
+                      <a:endParaRPr lang="en-US" sz="1400" dirty="0"/>
+                    </a:p>
+                  </a:txBody>
+                  <a:tcPr marL="91440" marR="91440" marT="45720" marB="45720" anchor="ctr">
+                    <a:lnL w="9525" cap="flat" cmpd="sng" algn="ctr">
+                      <a:solidFill>
+                        <a:srgbClr val="D5DEE8"/>
+                      </a:solidFill>
+                      <a:prstDash val="solid"/>
+                      <a:round/>
+                      <a:headEnd type="none" w="med" len="med"/>
+                      <a:tailEnd type="none" w="med" len="med"/>
+                    </a:lnL>
+                    <a:lnR w="9525" cap="flat" cmpd="sng" algn="ctr">
+                      <a:solidFill>
+                        <a:srgbClr val="D5DEE8"/>
+                      </a:solidFill>
+                      <a:prstDash val="solid"/>
+                      <a:round/>
+                      <a:headEnd type="none" w="med" len="med"/>
+                      <a:tailEnd type="none" w="med" len="med"/>
+                    </a:lnR>
+                    <a:lnT w="9525" cap="flat" cmpd="sng" algn="ctr">
+                      <a:solidFill>
+                        <a:srgbClr val="D5DEE8"/>
+                      </a:solidFill>
+                      <a:prstDash val="solid"/>
+                      <a:round/>
+                      <a:headEnd type="none" w="med" len="med"/>
+                      <a:tailEnd type="none" w="med" len="med"/>
+                    </a:lnT>
+                    <a:lnB w="9525" cap="flat" cmpd="sng" algn="ctr">
+                      <a:solidFill>
+                        <a:srgbClr val="D5DEE8"/>
+                      </a:solidFill>
+                      <a:prstDash val="solid"/>
+                      <a:round/>
+                      <a:headEnd type="none" w="med" len="med"/>
+                      <a:tailEnd type="none" w="med" len="med"/>
+                    </a:lnB>
+                    <a:solidFill>
+                      <a:schemeClr val="tx2"/>
+                    </a:solidFill>
+                  </a:tcPr>
+                </a:tc>
+                <a:tc>
+                  <a:txBody>
+                    <a:bodyPr/>
+                    <a:lstStyle/>
+                    <a:p>
+                      <a:pPr indent="0" marL="0">
+                        <a:buNone/>
+                      </a:pPr>
+                      <a:r>
+                        <a:rPr lang="en-US" sz="1400" b="1" dirty="0">
+                          <a:solidFill>
+                            <a:schemeClr val="bg1"/>
+                          </a:solidFill>
+                        </a:rPr>
+                        <a:t>Result</a:t>
+                      </a:r>
+                      <a:endParaRPr lang="en-US" sz="1400" dirty="0"/>
+                    </a:p>
+                  </a:txBody>
+                  <a:tcPr marL="91440" marR="91440" marT="45720" marB="45720" anchor="ctr">
+                    <a:lnL w="9525" cap="flat" cmpd="sng" algn="ctr">
+                      <a:solidFill>
+                        <a:srgbClr val="D5DEE8"/>
+                      </a:solidFill>
+                      <a:prstDash val="solid"/>
+                      <a:round/>
+                      <a:headEnd type="none" w="med" len="med"/>
+                      <a:tailEnd type="none" w="med" len="med"/>
+                    </a:lnL>
+                    <a:lnR w="9525" cap="flat" cmpd="sng" algn="ctr">
+                      <a:solidFill>
+                        <a:srgbClr val="D5DEE8"/>
+                      </a:solidFill>
+                      <a:prstDash val="solid"/>
+                      <a:round/>
+                      <a:headEnd type="none" w="med" len="med"/>
+                      <a:tailEnd type="none" w="med" len="med"/>
+                    </a:lnR>
+                    <a:lnT w="9525" cap="flat" cmpd="sng" algn="ctr">
+                      <a:solidFill>
+                        <a:srgbClr val="D5DEE8"/>
+                      </a:solidFill>
+                      <a:prstDash val="solid"/>
+                      <a:round/>
+                      <a:headEnd type="none" w="med" len="med"/>
+                      <a:tailEnd type="none" w="med" len="med"/>
+                    </a:lnT>
+                    <a:lnB w="9525" cap="flat" cmpd="sng" algn="ctr">
+                      <a:solidFill>
+                        <a:srgbClr val="D5DEE8"/>
+                      </a:solidFill>
+                      <a:prstDash val="solid"/>
+                      <a:round/>
+                      <a:headEnd type="none" w="med" len="med"/>
+                      <a:tailEnd type="none" w="med" len="med"/>
+                    </a:lnB>
+                    <a:solidFill>
+                      <a:schemeClr val="tx2"/>
+                    </a:solidFill>
+                  </a:tcPr>
+                </a:tc>
+              </a:tr>
+              <a:tr h="457200">
+                <a:tc>
+                  <a:txBody>
+                    <a:bodyPr/>
+                    <a:lstStyle/>
+                    <a:p>
+                      <a:pPr indent="0" marL="0">
+                        <a:buNone/>
+                      </a:pPr>
+                      <a:r>
+                        <a:rPr lang="en-US" sz="1400" b="1" dirty="0">
+                          <a:solidFill>
+                            <a:schemeClr val="tx1"/>
+                          </a:solidFill>
+                        </a:rPr>
+                        <a:t>Site over HTTP</a:t>
+                      </a:r>
+                      <a:endParaRPr lang="en-US" sz="1400" dirty="0"/>
+                    </a:p>
+                  </a:txBody>
+                  <a:tcPr marL="91440" marR="91440" marT="45720" marB="45720" anchor="ctr">
+                    <a:lnL w="9525" cap="flat" cmpd="sng" algn="ctr">
+                      <a:solidFill>
+                        <a:srgbClr val="D5DEE8"/>
+                      </a:solidFill>
+                      <a:prstDash val="solid"/>
+                      <a:round/>
+                      <a:headEnd type="none" w="med" len="med"/>
+                      <a:tailEnd type="none" w="med" len="med"/>
+                    </a:lnL>
+                    <a:lnR w="9525" cap="flat" cmpd="sng" algn="ctr">
+                      <a:solidFill>
+                        <a:srgbClr val="D5DEE8"/>
+                      </a:solidFill>
+                      <a:prstDash val="solid"/>
+                      <a:round/>
+                      <a:headEnd type="none" w="med" len="med"/>
+                      <a:tailEnd type="none" w="med" len="med"/>
+                    </a:lnR>
+                    <a:lnT w="9525" cap="flat" cmpd="sng" algn="ctr">
+                      <a:solidFill>
+                        <a:srgbClr val="D5DEE8"/>
+                      </a:solidFill>
+                      <a:prstDash val="solid"/>
+                      <a:round/>
+                      <a:headEnd type="none" w="med" len="med"/>
+                      <a:tailEnd type="none" w="med" len="med"/>
+                    </a:lnT>
+                    <a:lnB w="9525" cap="flat" cmpd="sng" algn="ctr">
+                      <a:solidFill>
+                        <a:srgbClr val="D5DEE8"/>
+                      </a:solidFill>
+                      <a:prstDash val="solid"/>
+                      <a:round/>
+                      <a:headEnd type="none" w="med" len="med"/>
+                      <a:tailEnd type="none" w="med" len="med"/>
+                    </a:lnB>
+                    <a:solidFill>
+                      <a:schemeClr val="bg1"/>
+                    </a:solidFill>
+                  </a:tcPr>
+                </a:tc>
+                <a:tc>
+                  <a:txBody>
+                    <a:bodyPr/>
+                    <a:lstStyle/>
+                    <a:p>
+                      <a:pPr indent="0" marL="0">
+                        <a:buNone/>
+                      </a:pPr>
+                      <a:r>
+                        <a:rPr lang="en-US" sz="1400" dirty="0">
+                          <a:solidFill>
+                            <a:schemeClr val="tx1"/>
+                          </a:solidFill>
+                        </a:rPr>
+                        <a:t>200, login page renders</a:t>
+                      </a:r>
+                      <a:endParaRPr lang="en-US" sz="1400" dirty="0"/>
+                    </a:p>
+                  </a:txBody>
+                  <a:tcPr marL="91440" marR="91440" marT="45720" marB="45720" anchor="ctr">
+                    <a:lnL w="9525" cap="flat" cmpd="sng" algn="ctr">
+                      <a:solidFill>
+                        <a:srgbClr val="D5DEE8"/>
+                      </a:solidFill>
+                      <a:prstDash val="solid"/>
+                      <a:round/>
+                      <a:headEnd type="none" w="med" len="med"/>
+                      <a:tailEnd type="none" w="med" len="med"/>
+                    </a:lnL>
+                    <a:lnR w="9525" cap="flat" cmpd="sng" algn="ctr">
+                      <a:solidFill>
+                        <a:srgbClr val="D5DEE8"/>
+                      </a:solidFill>
+                      <a:prstDash val="solid"/>
+                      <a:round/>
+                      <a:headEnd type="none" w="med" len="med"/>
+                      <a:tailEnd type="none" w="med" len="med"/>
+                    </a:lnR>
+                    <a:lnT w="9525" cap="flat" cmpd="sng" algn="ctr">
+                      <a:solidFill>
+                        <a:srgbClr val="D5DEE8"/>
+                      </a:solidFill>
+                      <a:prstDash val="solid"/>
+                      <a:round/>
+                      <a:headEnd type="none" w="med" len="med"/>
+                      <a:tailEnd type="none" w="med" len="med"/>
+                    </a:lnT>
+                    <a:lnB w="9525" cap="flat" cmpd="sng" algn="ctr">
+                      <a:solidFill>
+                        <a:srgbClr val="D5DEE8"/>
+                      </a:solidFill>
+                      <a:prstDash val="solid"/>
+                      <a:round/>
+                      <a:headEnd type="none" w="med" len="med"/>
+                      <a:tailEnd type="none" w="med" len="med"/>
+                    </a:lnB>
+                    <a:solidFill>
+                      <a:schemeClr val="bg1"/>
+                    </a:solidFill>
+                  </a:tcPr>
+                </a:tc>
+              </a:tr>
+              <a:tr h="457200">
+                <a:tc>
+                  <a:txBody>
+                    <a:bodyPr/>
+                    <a:lstStyle/>
+                    <a:p>
+                      <a:pPr indent="0" marL="0">
+                        <a:buNone/>
+                      </a:pPr>
+                      <a:r>
+                        <a:rPr lang="en-US" sz="1400" b="1" dirty="0">
+                          <a:solidFill>
+                            <a:schemeClr val="tx1"/>
+                          </a:solidFill>
+                        </a:rPr>
+                        <a:t>API health endpoint</a:t>
+                      </a:r>
+                      <a:endParaRPr lang="en-US" sz="1400" dirty="0"/>
+                    </a:p>
+                  </a:txBody>
+                  <a:tcPr marL="91440" marR="91440" marT="45720" marB="45720" anchor="ctr">
+                    <a:lnL w="9525" cap="flat" cmpd="sng" algn="ctr">
+                      <a:solidFill>
+                        <a:srgbClr val="D5DEE8"/>
+                      </a:solidFill>
+                      <a:prstDash val="solid"/>
+                      <a:round/>
+                      <a:headEnd type="none" w="med" len="med"/>
+                      <a:tailEnd type="none" w="med" len="med"/>
+                    </a:lnL>
+                    <a:lnR w="9525" cap="flat" cmpd="sng" algn="ctr">
+                      <a:solidFill>
+                        <a:srgbClr val="D5DEE8"/>
+                      </a:solidFill>
+                      <a:prstDash val="solid"/>
+                      <a:round/>
+                      <a:headEnd type="none" w="med" len="med"/>
+                      <a:tailEnd type="none" w="med" len="med"/>
+                    </a:lnR>
+                    <a:lnT w="9525" cap="flat" cmpd="sng" algn="ctr">
+                      <a:solidFill>
+                        <a:srgbClr val="D5DEE8"/>
+                      </a:solidFill>
+                      <a:prstDash val="solid"/>
+                      <a:round/>
+                      <a:headEnd type="none" w="med" len="med"/>
+                      <a:tailEnd type="none" w="med" len="med"/>
+                    </a:lnT>
+                    <a:lnB w="9525" cap="flat" cmpd="sng" algn="ctr">
+                      <a:solidFill>
+                        <a:srgbClr val="D5DEE8"/>
+                      </a:solidFill>
+                      <a:prstDash val="solid"/>
+                      <a:round/>
+                      <a:headEnd type="none" w="med" len="med"/>
+                      <a:tailEnd type="none" w="med" len="med"/>
+                    </a:lnB>
+                    <a:solidFill>
+                      <a:schemeClr val="bg1"/>
+                    </a:solidFill>
+                  </a:tcPr>
+                </a:tc>
+                <a:tc>
+                  <a:txBody>
+                    <a:bodyPr/>
+                    <a:lstStyle/>
+                    <a:p>
+                      <a:pPr indent="0" marL="0">
+                        <a:buNone/>
+                      </a:pPr>
+                      <a:r>
+                        <a:rPr lang="en-US" sz="1400" dirty="0">
+                          <a:solidFill>
+                            <a:schemeClr val="tx1"/>
+                          </a:solidFill>
+                        </a:rPr>
+                        <a:t>200, status ok</a:t>
+                      </a:r>
+                      <a:endParaRPr lang="en-US" sz="1400" dirty="0"/>
+                    </a:p>
+                  </a:txBody>
+                  <a:tcPr marL="91440" marR="91440" marT="45720" marB="45720" anchor="ctr">
+                    <a:lnL w="9525" cap="flat" cmpd="sng" algn="ctr">
+                      <a:solidFill>
+                        <a:srgbClr val="D5DEE8"/>
+                      </a:solidFill>
+                      <a:prstDash val="solid"/>
+                      <a:round/>
+                      <a:headEnd type="none" w="med" len="med"/>
+                      <a:tailEnd type="none" w="med" len="med"/>
+                    </a:lnL>
+                    <a:lnR w="9525" cap="flat" cmpd="sng" algn="ctr">
+                      <a:solidFill>
+                        <a:srgbClr val="D5DEE8"/>
+                      </a:solidFill>
+                      <a:prstDash val="solid"/>
+                      <a:round/>
+                      <a:headEnd type="none" w="med" len="med"/>
+                      <a:tailEnd type="none" w="med" len="med"/>
+                    </a:lnR>
+                    <a:lnT w="9525" cap="flat" cmpd="sng" algn="ctr">
+                      <a:solidFill>
+                        <a:srgbClr val="D5DEE8"/>
+                      </a:solidFill>
+                      <a:prstDash val="solid"/>
+                      <a:round/>
+                      <a:headEnd type="none" w="med" len="med"/>
+                      <a:tailEnd type="none" w="med" len="med"/>
+                    </a:lnT>
+                    <a:lnB w="9525" cap="flat" cmpd="sng" algn="ctr">
+                      <a:solidFill>
+                        <a:srgbClr val="D5DEE8"/>
+                      </a:solidFill>
+                      <a:prstDash val="solid"/>
+                      <a:round/>
+                      <a:headEnd type="none" w="med" len="med"/>
+                      <a:tailEnd type="none" w="med" len="med"/>
+                    </a:lnB>
+                    <a:solidFill>
+                      <a:schemeClr val="bg1"/>
+                    </a:solidFill>
+                  </a:tcPr>
+                </a:tc>
+              </a:tr>
+              <a:tr h="457200">
+                <a:tc>
+                  <a:txBody>
+                    <a:bodyPr/>
+                    <a:lstStyle/>
+                    <a:p>
+                      <a:pPr indent="0" marL="0">
+                        <a:buNone/>
+                      </a:pPr>
+                      <a:r>
+                        <a:rPr lang="en-US" sz="1400" b="1" dirty="0">
+                          <a:solidFill>
+                            <a:schemeClr val="tx1"/>
+                          </a:solidFill>
+                        </a:rPr>
+                        <a:t>8 protected endpoints, no token</a:t>
+                      </a:r>
+                      <a:endParaRPr lang="en-US" sz="1400" dirty="0"/>
+                    </a:p>
+                  </a:txBody>
+                  <a:tcPr marL="91440" marR="91440" marT="45720" marB="45720" anchor="ctr">
+                    <a:lnL w="9525" cap="flat" cmpd="sng" algn="ctr">
+                      <a:solidFill>
+                        <a:srgbClr val="D5DEE8"/>
+                      </a:solidFill>
+                      <a:prstDash val="solid"/>
+                      <a:round/>
+                      <a:headEnd type="none" w="med" len="med"/>
+                      <a:tailEnd type="none" w="med" len="med"/>
+                    </a:lnL>
+                    <a:lnR w="9525" cap="flat" cmpd="sng" algn="ctr">
+                      <a:solidFill>
+                        <a:srgbClr val="D5DEE8"/>
+                      </a:solidFill>
+                      <a:prstDash val="solid"/>
+                      <a:round/>
+                      <a:headEnd type="none" w="med" len="med"/>
+                      <a:tailEnd type="none" w="med" len="med"/>
+                    </a:lnR>
+                    <a:lnT w="9525" cap="flat" cmpd="sng" algn="ctr">
+                      <a:solidFill>
+                        <a:srgbClr val="D5DEE8"/>
+                      </a:solidFill>
+                      <a:prstDash val="solid"/>
+                      <a:round/>
+                      <a:headEnd type="none" w="med" len="med"/>
+                      <a:tailEnd type="none" w="med" len="med"/>
+                    </a:lnT>
+                    <a:lnB w="9525" cap="flat" cmpd="sng" algn="ctr">
+                      <a:solidFill>
+                        <a:srgbClr val="D5DEE8"/>
+                      </a:solidFill>
+                      <a:prstDash val="solid"/>
+                      <a:round/>
+                      <a:headEnd type="none" w="med" len="med"/>
+                      <a:tailEnd type="none" w="med" len="med"/>
+                    </a:lnB>
+                    <a:solidFill>
+                      <a:schemeClr val="bg1"/>
+                    </a:solidFill>
+                  </a:tcPr>
+                </a:tc>
+                <a:tc>
+                  <a:txBody>
+                    <a:bodyPr/>
+                    <a:lstStyle/>
+                    <a:p>
+                      <a:pPr indent="0" marL="0">
+                        <a:buNone/>
+                      </a:pPr>
+                      <a:r>
+                        <a:rPr lang="en-US" sz="1400" dirty="0">
+                          <a:solidFill>
+                            <a:schemeClr val="tx1"/>
+                          </a:solidFill>
+                        </a:rPr>
+                        <a:t>All return 401</a:t>
+                      </a:r>
+                      <a:endParaRPr lang="en-US" sz="1400" dirty="0"/>
+                    </a:p>
+                  </a:txBody>
+                  <a:tcPr marL="91440" marR="91440" marT="45720" marB="45720" anchor="ctr">
+                    <a:lnL w="9525" cap="flat" cmpd="sng" algn="ctr">
+                      <a:solidFill>
+                        <a:srgbClr val="D5DEE8"/>
+                      </a:solidFill>
+                      <a:prstDash val="solid"/>
+                      <a:round/>
+                      <a:headEnd type="none" w="med" len="med"/>
+                      <a:tailEnd type="none" w="med" len="med"/>
+                    </a:lnL>
+                    <a:lnR w="9525" cap="flat" cmpd="sng" algn="ctr">
+                      <a:solidFill>
+                        <a:srgbClr val="D5DEE8"/>
+                      </a:solidFill>
+                      <a:prstDash val="solid"/>
+                      <a:round/>
+                      <a:headEnd type="none" w="med" len="med"/>
+                      <a:tailEnd type="none" w="med" len="med"/>
+                    </a:lnR>
+                    <a:lnT w="9525" cap="flat" cmpd="sng" algn="ctr">
+                      <a:solidFill>
+                        <a:srgbClr val="D5DEE8"/>
+                      </a:solidFill>
+                      <a:prstDash val="solid"/>
+                      <a:round/>
+                      <a:headEnd type="none" w="med" len="med"/>
+                      <a:tailEnd type="none" w="med" len="med"/>
+                    </a:lnT>
+                    <a:lnB w="9525" cap="flat" cmpd="sng" algn="ctr">
+                      <a:solidFill>
+                        <a:srgbClr val="D5DEE8"/>
+                      </a:solidFill>
+                      <a:prstDash val="solid"/>
+                      <a:round/>
+                      <a:headEnd type="none" w="med" len="med"/>
+                      <a:tailEnd type="none" w="med" len="med"/>
+                    </a:lnB>
+                    <a:solidFill>
+                      <a:schemeClr val="bg1"/>
+                    </a:solidFill>
+                  </a:tcPr>
+                </a:tc>
+              </a:tr>
+              <a:tr h="457200">
+                <a:tc>
+                  <a:txBody>
+                    <a:bodyPr/>
+                    <a:lstStyle/>
+                    <a:p>
+                      <a:pPr indent="0" marL="0">
+                        <a:buNone/>
+                      </a:pPr>
+                      <a:r>
+                        <a:rPr lang="en-US" sz="1400" b="1" dirty="0">
+                          <a:solidFill>
+                            <a:schemeClr val="tx1"/>
+                          </a:solidFill>
+                        </a:rPr>
+                        <a:t>Sign-up with bad input</a:t>
+                      </a:r>
+                      <a:endParaRPr lang="en-US" sz="1400" dirty="0"/>
+                    </a:p>
+                  </a:txBody>
+                  <a:tcPr marL="91440" marR="91440" marT="45720" marB="45720" anchor="ctr">
+                    <a:lnL w="9525" cap="flat" cmpd="sng" algn="ctr">
+                      <a:solidFill>
+                        <a:srgbClr val="D5DEE8"/>
+                      </a:solidFill>
+                      <a:prstDash val="solid"/>
+                      <a:round/>
+                      <a:headEnd type="none" w="med" len="med"/>
+                      <a:tailEnd type="none" w="med" len="med"/>
+                    </a:lnL>
+                    <a:lnR w="9525" cap="flat" cmpd="sng" algn="ctr">
+                      <a:solidFill>
+                        <a:srgbClr val="D5DEE8"/>
+                      </a:solidFill>
+                      <a:prstDash val="solid"/>
+                      <a:round/>
+                      <a:headEnd type="none" w="med" len="med"/>
+                      <a:tailEnd type="none" w="med" len="med"/>
+                    </a:lnR>
+                    <a:lnT w="9525" cap="flat" cmpd="sng" algn="ctr">
+                      <a:solidFill>
+                        <a:srgbClr val="D5DEE8"/>
+                      </a:solidFill>
+                      <a:prstDash val="solid"/>
+                      <a:round/>
+                      <a:headEnd type="none" w="med" len="med"/>
+                      <a:tailEnd type="none" w="med" len="med"/>
+                    </a:lnT>
+                    <a:lnB w="9525" cap="flat" cmpd="sng" algn="ctr">
+                      <a:solidFill>
+                        <a:srgbClr val="D5DEE8"/>
+                      </a:solidFill>
+                      <a:prstDash val="solid"/>
+                      <a:round/>
+                      <a:headEnd type="none" w="med" len="med"/>
+                      <a:tailEnd type="none" w="med" len="med"/>
+                    </a:lnB>
+                    <a:solidFill>
+                      <a:schemeClr val="bg1"/>
+                    </a:solidFill>
+                  </a:tcPr>
+                </a:tc>
+                <a:tc>
+                  <a:txBody>
+                    <a:bodyPr/>
+                    <a:lstStyle/>
+                    <a:p>
+                      <a:pPr indent="0" marL="0">
+                        <a:buNone/>
+                      </a:pPr>
+                      <a:r>
+                        <a:rPr lang="en-US" sz="1400" dirty="0">
+                          <a:solidFill>
+                            <a:schemeClr val="tx1"/>
+                          </a:solidFill>
+                        </a:rPr>
+                        <a:t>400 with validation errors</a:t>
+                      </a:r>
+                      <a:endParaRPr lang="en-US" sz="1400" dirty="0"/>
+                    </a:p>
+                  </a:txBody>
+                  <a:tcPr marL="91440" marR="91440" marT="45720" marB="45720" anchor="ctr">
+                    <a:lnL w="9525" cap="flat" cmpd="sng" algn="ctr">
+                      <a:solidFill>
+                        <a:srgbClr val="D5DEE8"/>
+                      </a:solidFill>
+                      <a:prstDash val="solid"/>
+                      <a:round/>
+                      <a:headEnd type="none" w="med" len="med"/>
+                      <a:tailEnd type="none" w="med" len="med"/>
+                    </a:lnL>
+                    <a:lnR w="9525" cap="flat" cmpd="sng" algn="ctr">
+                      <a:solidFill>
+                        <a:srgbClr val="D5DEE8"/>
+                      </a:solidFill>
+                      <a:prstDash val="solid"/>
+                      <a:round/>
+                      <a:headEnd type="none" w="med" len="med"/>
+                      <a:tailEnd type="none" w="med" len="med"/>
+                    </a:lnR>
+                    <a:lnT w="9525" cap="flat" cmpd="sng" algn="ctr">
+                      <a:solidFill>
+                        <a:srgbClr val="D5DEE8"/>
+                      </a:solidFill>
+                      <a:prstDash val="solid"/>
+                      <a:round/>
+                      <a:headEnd type="none" w="med" len="med"/>
+                      <a:tailEnd type="none" w="med" len="med"/>
+                    </a:lnT>
+                    <a:lnB w="9525" cap="flat" cmpd="sng" algn="ctr">
+                      <a:solidFill>
+                        <a:srgbClr val="D5DEE8"/>
+                      </a:solidFill>
+                      <a:prstDash val="solid"/>
+                      <a:round/>
+                      <a:headEnd type="none" w="med" len="med"/>
+                      <a:tailEnd type="none" w="med" len="med"/>
+                    </a:lnB>
+                    <a:solidFill>
+                      <a:schemeClr val="bg1"/>
+                    </a:solidFill>
+                  </a:tcPr>
+                </a:tc>
+              </a:tr>
+              <a:tr h="457200">
+                <a:tc>
+                  <a:txBody>
+                    <a:bodyPr/>
+                    <a:lstStyle/>
+                    <a:p>
+                      <a:pPr indent="0" marL="0">
+                        <a:buNone/>
+                      </a:pPr>
+                      <a:r>
+                        <a:rPr lang="en-US" sz="1400" b="1" dirty="0">
+                          <a:solidFill>
+                            <a:schemeClr val="tx1"/>
+                          </a:solidFill>
+                        </a:rPr>
+                        <a:t>Login with wrong credentials</a:t>
+                      </a:r>
+                      <a:endParaRPr lang="en-US" sz="1400" dirty="0"/>
+                    </a:p>
+                  </a:txBody>
+                  <a:tcPr marL="91440" marR="91440" marT="45720" marB="45720" anchor="ctr">
+                    <a:lnL w="9525" cap="flat" cmpd="sng" algn="ctr">
+                      <a:solidFill>
+                        <a:srgbClr val="D5DEE8"/>
+                      </a:solidFill>
+                      <a:prstDash val="solid"/>
+                      <a:round/>
+                      <a:headEnd type="none" w="med" len="med"/>
+                      <a:tailEnd type="none" w="med" len="med"/>
+                    </a:lnL>
+                    <a:lnR w="9525" cap="flat" cmpd="sng" algn="ctr">
+                      <a:solidFill>
+                        <a:srgbClr val="D5DEE8"/>
+                      </a:solidFill>
+                      <a:prstDash val="solid"/>
+                      <a:round/>
+                      <a:headEnd type="none" w="med" len="med"/>
+                      <a:tailEnd type="none" w="med" len="med"/>
+                    </a:lnR>
+                    <a:lnT w="9525" cap="flat" cmpd="sng" algn="ctr">
+                      <a:solidFill>
+                        <a:srgbClr val="D5DEE8"/>
+                      </a:solidFill>
+                      <a:prstDash val="solid"/>
+                      <a:round/>
+                      <a:headEnd type="none" w="med" len="med"/>
+                      <a:tailEnd type="none" w="med" len="med"/>
+                    </a:lnT>
+                    <a:lnB w="9525" cap="flat" cmpd="sng" algn="ctr">
+                      <a:solidFill>
+                        <a:srgbClr val="D5DEE8"/>
+                      </a:solidFill>
+                      <a:prstDash val="solid"/>
+                      <a:round/>
+                      <a:headEnd type="none" w="med" len="med"/>
+                      <a:tailEnd type="none" w="med" len="med"/>
+                    </a:lnB>
+                    <a:solidFill>
+                      <a:schemeClr val="bg1"/>
+                    </a:solidFill>
+                  </a:tcPr>
+                </a:tc>
+                <a:tc>
+                  <a:txBody>
+                    <a:bodyPr/>
+                    <a:lstStyle/>
+                    <a:p>
+                      <a:pPr indent="0" marL="0">
+                        <a:buNone/>
+                      </a:pPr>
+                      <a:r>
+                        <a:rPr lang="en-US" sz="1400" dirty="0">
+                          <a:solidFill>
+                            <a:schemeClr val="tx1"/>
+                          </a:solidFill>
+                        </a:rPr>
+                        <a:t>401 in about 25 ms, so the database is reachable</a:t>
+                      </a:r>
+                      <a:endParaRPr lang="en-US" sz="1400" dirty="0"/>
+                    </a:p>
+                  </a:txBody>
+                  <a:tcPr marL="91440" marR="91440" marT="45720" marB="45720" anchor="ctr">
+                    <a:lnL w="9525" cap="flat" cmpd="sng" algn="ctr">
+                      <a:solidFill>
+                        <a:srgbClr val="D5DEE8"/>
+                      </a:solidFill>
+                      <a:prstDash val="solid"/>
+                      <a:round/>
+                      <a:headEnd type="none" w="med" len="med"/>
+                      <a:tailEnd type="none" w="med" len="med"/>
+                    </a:lnL>
+                    <a:lnR w="9525" cap="flat" cmpd="sng" algn="ctr">
+                      <a:solidFill>
+                        <a:srgbClr val="D5DEE8"/>
+                      </a:solidFill>
+                      <a:prstDash val="solid"/>
+                      <a:round/>
+                      <a:headEnd type="none" w="med" len="med"/>
+                      <a:tailEnd type="none" w="med" len="med"/>
+                    </a:lnR>
+                    <a:lnT w="9525" cap="flat" cmpd="sng" algn="ctr">
+                      <a:solidFill>
+                        <a:srgbClr val="D5DEE8"/>
+                      </a:solidFill>
+                      <a:prstDash val="solid"/>
+                      <a:round/>
+                      <a:headEnd type="none" w="med" len="med"/>
+                      <a:tailEnd type="none" w="med" len="med"/>
+                    </a:lnT>
+                    <a:lnB w="9525" cap="flat" cmpd="sng" algn="ctr">
+                      <a:solidFill>
+                        <a:srgbClr val="D5DEE8"/>
+                      </a:solidFill>
+                      <a:prstDash val="solid"/>
+                      <a:round/>
+                      <a:headEnd type="none" w="med" len="med"/>
+                      <a:tailEnd type="none" w="med" len="med"/>
+                    </a:lnB>
+                    <a:solidFill>
+                      <a:schemeClr val="bg1"/>
+                    </a:solidFill>
+                  </a:tcPr>
+                </a:tc>
+              </a:tr>
+              <a:tr h="457200">
+                <a:tc>
+                  <a:txBody>
+                    <a:bodyPr/>
+                    <a:lstStyle/>
+                    <a:p>
+                      <a:pPr indent="0" marL="0">
+                        <a:buNone/>
+                      </a:pPr>
+                      <a:r>
+                        <a:rPr lang="en-US" sz="1400" b="1" dirty="0">
+                          <a:solidFill>
+                            <a:schemeClr val="tx1"/>
+                          </a:solidFill>
+                        </a:rPr>
+                        <a:t>CloudFormation stack</a:t>
+                      </a:r>
+                      <a:endParaRPr lang="en-US" sz="1400" dirty="0"/>
+                    </a:p>
+                  </a:txBody>
+                  <a:tcPr marL="91440" marR="91440" marT="45720" marB="45720" anchor="ctr">
+                    <a:lnL w="9525" cap="flat" cmpd="sng" algn="ctr">
+                      <a:solidFill>
+                        <a:srgbClr val="D5DEE8"/>
+                      </a:solidFill>
+                      <a:prstDash val="solid"/>
+                      <a:round/>
+                      <a:headEnd type="none" w="med" len="med"/>
+                      <a:tailEnd type="none" w="med" len="med"/>
+                    </a:lnL>
+                    <a:lnR w="9525" cap="flat" cmpd="sng" algn="ctr">
+                      <a:solidFill>
+                        <a:srgbClr val="D5DEE8"/>
+                      </a:solidFill>
+                      <a:prstDash val="solid"/>
+                      <a:round/>
+                      <a:headEnd type="none" w="med" len="med"/>
+                      <a:tailEnd type="none" w="med" len="med"/>
+                    </a:lnR>
+                    <a:lnT w="9525" cap="flat" cmpd="sng" algn="ctr">
+                      <a:solidFill>
+                        <a:srgbClr val="D5DEE8"/>
+                      </a:solidFill>
+                      <a:prstDash val="solid"/>
+                      <a:round/>
+                      <a:headEnd type="none" w="med" len="med"/>
+                      <a:tailEnd type="none" w="med" len="med"/>
+                    </a:lnT>
+                    <a:lnB w="9525" cap="flat" cmpd="sng" algn="ctr">
+                      <a:solidFill>
+                        <a:srgbClr val="D5DEE8"/>
+                      </a:solidFill>
+                      <a:prstDash val="solid"/>
+                      <a:round/>
+                      <a:headEnd type="none" w="med" len="med"/>
+                      <a:tailEnd type="none" w="med" len="med"/>
+                    </a:lnB>
+                    <a:solidFill>
+                      <a:schemeClr val="bg1"/>
+                    </a:solidFill>
+                  </a:tcPr>
+                </a:tc>
+                <a:tc>
+                  <a:txBody>
+                    <a:bodyPr/>
+                    <a:lstStyle/>
+                    <a:p>
+                      <a:pPr indent="0" marL="0">
+                        <a:buNone/>
+                      </a:pPr>
+                      <a:r>
+                        <a:rPr lang="en-US" sz="1400" dirty="0">
+                          <a:solidFill>
+                            <a:schemeClr val="tx1"/>
+                          </a:solidFill>
+                        </a:rPr>
+                        <a:t>UPDATE_COMPLETE, alarms and dashboard live</a:t>
+                      </a:r>
+                      <a:endParaRPr lang="en-US" sz="1400" dirty="0"/>
+                    </a:p>
+                  </a:txBody>
+                  <a:tcPr marL="91440" marR="91440" marT="45720" marB="45720" anchor="ctr">
+                    <a:lnL w="9525" cap="flat" cmpd="sng" algn="ctr">
+                      <a:solidFill>
+                        <a:srgbClr val="D5DEE8"/>
+                      </a:solidFill>
+                      <a:prstDash val="solid"/>
+                      <a:round/>
+                      <a:headEnd type="none" w="med" len="med"/>
+                      <a:tailEnd type="none" w="med" len="med"/>
+                    </a:lnL>
+                    <a:lnR w="9525" cap="flat" cmpd="sng" algn="ctr">
+                      <a:solidFill>
+                        <a:srgbClr val="D5DEE8"/>
+                      </a:solidFill>
+                      <a:prstDash val="solid"/>
+                      <a:round/>
+                      <a:headEnd type="none" w="med" len="med"/>
+                      <a:tailEnd type="none" w="med" len="med"/>
+                    </a:lnR>
+                    <a:lnT w="9525" cap="flat" cmpd="sng" algn="ctr">
+                      <a:solidFill>
+                        <a:srgbClr val="D5DEE8"/>
+                      </a:solidFill>
+                      <a:prstDash val="solid"/>
+                      <a:round/>
+                      <a:headEnd type="none" w="med" len="med"/>
+                      <a:tailEnd type="none" w="med" len="med"/>
+                    </a:lnT>
+                    <a:lnB w="9525" cap="flat" cmpd="sng" algn="ctr">
+                      <a:solidFill>
+                        <a:srgbClr val="D5DEE8"/>
+                      </a:solidFill>
+                      <a:prstDash val="solid"/>
+                      <a:round/>
+                      <a:headEnd type="none" w="med" len="med"/>
+                      <a:tailEnd type="none" w="med" len="med"/>
+                    </a:lnB>
+                    <a:solidFill>
+                      <a:schemeClr val="bg1"/>
+                    </a:solidFill>
+                  </a:tcPr>
+                </a:tc>
+              </a:tr>
+            </a:tbl>
+          </a:graphicData>
+        </a:graphic>
+      </p:graphicFrame>
       <p:sp>
         <p:nvSpPr>
           <p:cNvPr id="25" name="Slide Number Placeholder 0"/>
@@ -3145,6 +3311,936 @@
 <file path=ppt/slides/slide11.xml><?xml version="1.0" encoding="utf-8"?>
 <p:sld xmlns:a="http://schemas.openxmlformats.org/drawingml/2006/main" xmlns:r="http://schemas.openxmlformats.org/officeDocument/2006/relationships" xmlns:p="http://schemas.openxmlformats.org/presentationml/2006/main">
   <p:cSld name="Slide 11">
+    <p:spTree>
+      <p:nvGrpSpPr>
+        <p:cNvPr id="1" name=""/>
+        <p:cNvGrpSpPr/>
+        <p:nvPr/>
+      </p:nvGrpSpPr>
+      <p:grpSpPr>
+        <a:xfrm>
+          <a:off x="0" y="0"/>
+          <a:ext cx="0" cy="0"/>
+          <a:chOff x="0" y="0"/>
+          <a:chExt cx="0" cy="0"/>
+        </a:xfrm>
+      </p:grpSpPr>
+      <p:sp>
+        <p:nvSpPr>
+          <p:cNvPr id="2" name="Text 0"/>
+          <p:cNvSpPr/>
+          <p:nvPr>
+            <p:ph idx="100" type="title" hasCustomPrompt="1"/>
+          </p:nvPr>
+        </p:nvSpPr>
+        <p:spPr>
+          <a:xfrm>
+            <a:off x="548640" y="320040"/>
+            <a:ext cx="8046720" cy="731520"/>
+          </a:xfrm>
+          <a:prstGeom prst="rect">
+            <a:avLst/>
+          </a:prstGeom>
+          <a:noFill/>
+          <a:ln/>
+        </p:spPr>
+        <p:txBody>
+          <a:bodyPr wrap="square" lIns="0" tIns="0" rIns="0" bIns="0" rtlCol="0" anchor="ctr"/>
+          <a:lstStyle/>
+          <a:p>
+            <a:pPr algn="l" indent="0" marL="0">
+              <a:buNone/>
+            </a:pPr>
+            <a:r>
+              <a:rPr lang="en-US" sz="3000" b="1" dirty="0">
+                <a:solidFill>
+                  <a:schemeClr val="tx2"/>
+                </a:solidFill>
+              </a:rPr>
+              <a:t>What comes next</a:t>
+            </a:r>
+            <a:endParaRPr lang="en-US" sz="3000" dirty="0"/>
+          </a:p>
+        </p:txBody>
+      </p:sp>
+      <p:sp>
+        <p:nvSpPr>
+          <p:cNvPr id="3" name="rm0"/>
+          <p:cNvSpPr/>
+          <p:nvPr/>
+        </p:nvSpPr>
+        <p:spPr>
+          <a:xfrm>
+            <a:off x="548640" y="1280160"/>
+            <a:ext cx="2560320" cy="1554480"/>
+          </a:xfrm>
+          <a:prstGeom prst="roundRect">
+            <a:avLst>
+              <a:gd name="adj" fmla="val 4706"/>
+            </a:avLst>
+          </a:prstGeom>
+          <a:solidFill>
+            <a:schemeClr val="bg2"/>
+          </a:solidFill>
+          <a:ln w="6350">
+            <a:solidFill>
+              <a:schemeClr val="bg2"/>
+            </a:solidFill>
+            <a:prstDash val="solid"/>
+          </a:ln>
+        </p:spPr>
+      </p:sp>
+      <p:sp>
+        <p:nvSpPr>
+          <p:cNvPr id="4" name="rn0"/>
+          <p:cNvSpPr txBox="1"/>
+          <p:nvPr/>
+        </p:nvSpPr>
+        <p:spPr>
+          <a:xfrm>
+            <a:off x="685800" y="1417320"/>
+            <a:ext cx="384048" cy="384048"/>
+          </a:xfrm>
+          <a:prstGeom prst="ellipse">
+            <a:avLst/>
+          </a:prstGeom>
+          <a:solidFill>
+            <a:schemeClr val="accent2"/>
+          </a:solidFill>
+          <a:ln/>
+        </p:spPr>
+        <p:txBody>
+          <a:bodyPr wrap="square" lIns="0" tIns="0" rIns="0" bIns="0" rtlCol="0" anchor="ctr"/>
+          <a:lstStyle/>
+          <a:p>
+            <a:pPr algn="ctr" indent="0" marL="0">
+              <a:buNone/>
+            </a:pPr>
+            <a:r>
+              <a:rPr lang="en-US" sz="1400" b="1" dirty="0">
+                <a:solidFill>
+                  <a:schemeClr val="bg1"/>
+                </a:solidFill>
+              </a:rPr>
+              <a:t>1</a:t>
+            </a:r>
+            <a:endParaRPr lang="en-US" sz="1400" dirty="0"/>
+          </a:p>
+        </p:txBody>
+      </p:sp>
+      <p:sp>
+        <p:nvSpPr>
+          <p:cNvPr id="5" name="Text 3"/>
+          <p:cNvSpPr txBox="1"/>
+          <p:nvPr/>
+        </p:nvSpPr>
+        <p:spPr>
+          <a:xfrm>
+            <a:off x="1143000" y="1417320"/>
+            <a:ext cx="1874520" cy="384048"/>
+          </a:xfrm>
+          <a:prstGeom prst="rect">
+            <a:avLst/>
+          </a:prstGeom>
+          <a:noFill/>
+          <a:ln/>
+        </p:spPr>
+        <p:txBody>
+          <a:bodyPr wrap="square" lIns="0" tIns="0" rIns="0" bIns="0" rtlCol="0" anchor="ctr"/>
+          <a:lstStyle/>
+          <a:p>
+            <a:pPr indent="0" marL="0">
+              <a:buNone/>
+            </a:pPr>
+            <a:r>
+              <a:rPr lang="en-US" sz="1600" b="1" dirty="0">
+                <a:solidFill>
+                  <a:schemeClr val="tx2"/>
+                </a:solidFill>
+              </a:rPr>
+              <a:t>HTTPS</a:t>
+            </a:r>
+            <a:endParaRPr lang="en-US" sz="1600" dirty="0"/>
+          </a:p>
+        </p:txBody>
+      </p:sp>
+      <p:sp>
+        <p:nvSpPr>
+          <p:cNvPr id="6" name="Text 4"/>
+          <p:cNvSpPr txBox="1"/>
+          <p:nvPr/>
+        </p:nvSpPr>
+        <p:spPr>
+          <a:xfrm>
+            <a:off x="685800" y="1901952"/>
+            <a:ext cx="2286000" cy="868680"/>
+          </a:xfrm>
+          <a:prstGeom prst="rect">
+            <a:avLst/>
+          </a:prstGeom>
+          <a:noFill/>
+          <a:ln/>
+        </p:spPr>
+        <p:txBody>
+          <a:bodyPr wrap="square" lIns="0" tIns="0" rIns="0" bIns="0" rtlCol="0" anchor="t"/>
+          <a:lstStyle/>
+          <a:p>
+            <a:pPr indent="0" marL="0">
+              <a:buNone/>
+            </a:pPr>
+            <a:r>
+              <a:rPr lang="en-US" sz="1400" dirty="0">
+                <a:solidFill>
+                  <a:schemeClr val="tx1"/>
+                </a:solidFill>
+              </a:rPr>
+              <a:t>CloudFront and an ACM certificate once verification clears</a:t>
+            </a:r>
+            <a:endParaRPr lang="en-US" sz="1400" dirty="0"/>
+          </a:p>
+        </p:txBody>
+      </p:sp>
+      <p:sp>
+        <p:nvSpPr>
+          <p:cNvPr id="7" name="rm1"/>
+          <p:cNvSpPr/>
+          <p:nvPr/>
+        </p:nvSpPr>
+        <p:spPr>
+          <a:xfrm>
+            <a:off x="3291840" y="1280160"/>
+            <a:ext cx="2560320" cy="1554480"/>
+          </a:xfrm>
+          <a:prstGeom prst="roundRect">
+            <a:avLst>
+              <a:gd name="adj" fmla="val 4706"/>
+            </a:avLst>
+          </a:prstGeom>
+          <a:solidFill>
+            <a:schemeClr val="bg2"/>
+          </a:solidFill>
+          <a:ln w="6350">
+            <a:solidFill>
+              <a:schemeClr val="bg2"/>
+            </a:solidFill>
+            <a:prstDash val="solid"/>
+          </a:ln>
+        </p:spPr>
+      </p:sp>
+      <p:sp>
+        <p:nvSpPr>
+          <p:cNvPr id="8" name="rn1"/>
+          <p:cNvSpPr txBox="1"/>
+          <p:nvPr/>
+        </p:nvSpPr>
+        <p:spPr>
+          <a:xfrm>
+            <a:off x="3429000" y="1417320"/>
+            <a:ext cx="384048" cy="384048"/>
+          </a:xfrm>
+          <a:prstGeom prst="ellipse">
+            <a:avLst/>
+          </a:prstGeom>
+          <a:solidFill>
+            <a:schemeClr val="accent2"/>
+          </a:solidFill>
+          <a:ln/>
+        </p:spPr>
+        <p:txBody>
+          <a:bodyPr wrap="square" lIns="0" tIns="0" rIns="0" bIns="0" rtlCol="0" anchor="ctr"/>
+          <a:lstStyle/>
+          <a:p>
+            <a:pPr algn="ctr" indent="0" marL="0">
+              <a:buNone/>
+            </a:pPr>
+            <a:r>
+              <a:rPr lang="en-US" sz="1400" b="1" dirty="0">
+                <a:solidFill>
+                  <a:schemeClr val="bg1"/>
+                </a:solidFill>
+              </a:rPr>
+              <a:t>2</a:t>
+            </a:r>
+            <a:endParaRPr lang="en-US" sz="1400" dirty="0"/>
+          </a:p>
+        </p:txBody>
+      </p:sp>
+      <p:sp>
+        <p:nvSpPr>
+          <p:cNvPr id="9" name="Text 7"/>
+          <p:cNvSpPr txBox="1"/>
+          <p:nvPr/>
+        </p:nvSpPr>
+        <p:spPr>
+          <a:xfrm>
+            <a:off x="3886200" y="1417320"/>
+            <a:ext cx="1874520" cy="384048"/>
+          </a:xfrm>
+          <a:prstGeom prst="rect">
+            <a:avLst/>
+          </a:prstGeom>
+          <a:noFill/>
+          <a:ln/>
+        </p:spPr>
+        <p:txBody>
+          <a:bodyPr wrap="square" lIns="0" tIns="0" rIns="0" bIns="0" rtlCol="0" anchor="ctr"/>
+          <a:lstStyle/>
+          <a:p>
+            <a:pPr indent="0" marL="0">
+              <a:buNone/>
+            </a:pPr>
+            <a:r>
+              <a:rPr lang="en-US" sz="1600" b="1" dirty="0">
+                <a:solidFill>
+                  <a:schemeClr val="tx2"/>
+                </a:solidFill>
+              </a:rPr>
+              <a:t>Custom domain</a:t>
+            </a:r>
+            <a:endParaRPr lang="en-US" sz="1600" dirty="0"/>
+          </a:p>
+        </p:txBody>
+      </p:sp>
+      <p:sp>
+        <p:nvSpPr>
+          <p:cNvPr id="10" name="Text 8"/>
+          <p:cNvSpPr txBox="1"/>
+          <p:nvPr/>
+        </p:nvSpPr>
+        <p:spPr>
+          <a:xfrm>
+            <a:off x="3429000" y="1901952"/>
+            <a:ext cx="2286000" cy="868680"/>
+          </a:xfrm>
+          <a:prstGeom prst="rect">
+            <a:avLst/>
+          </a:prstGeom>
+          <a:noFill/>
+          <a:ln/>
+        </p:spPr>
+        <p:txBody>
+          <a:bodyPr wrap="square" lIns="0" tIns="0" rIns="0" bIns="0" rtlCol="0" anchor="t"/>
+          <a:lstStyle/>
+          <a:p>
+            <a:pPr indent="0" marL="0">
+              <a:buNone/>
+            </a:pPr>
+            <a:r>
+              <a:rPr lang="en-US" sz="1400" dirty="0">
+                <a:solidFill>
+                  <a:schemeClr val="tx1"/>
+                </a:solidFill>
+              </a:rPr>
+              <a:t>Route 53 record for a friendly name</a:t>
+            </a:r>
+            <a:endParaRPr lang="en-US" sz="1400" dirty="0"/>
+          </a:p>
+        </p:txBody>
+      </p:sp>
+      <p:sp>
+        <p:nvSpPr>
+          <p:cNvPr id="11" name="rm2"/>
+          <p:cNvSpPr/>
+          <p:nvPr/>
+        </p:nvSpPr>
+        <p:spPr>
+          <a:xfrm>
+            <a:off x="6035040" y="1280160"/>
+            <a:ext cx="2560320" cy="1554480"/>
+          </a:xfrm>
+          <a:prstGeom prst="roundRect">
+            <a:avLst>
+              <a:gd name="adj" fmla="val 4706"/>
+            </a:avLst>
+          </a:prstGeom>
+          <a:solidFill>
+            <a:schemeClr val="bg2"/>
+          </a:solidFill>
+          <a:ln w="6350">
+            <a:solidFill>
+              <a:schemeClr val="bg2"/>
+            </a:solidFill>
+            <a:prstDash val="solid"/>
+          </a:ln>
+        </p:spPr>
+      </p:sp>
+      <p:sp>
+        <p:nvSpPr>
+          <p:cNvPr id="12" name="rn2"/>
+          <p:cNvSpPr txBox="1"/>
+          <p:nvPr/>
+        </p:nvSpPr>
+        <p:spPr>
+          <a:xfrm>
+            <a:off x="6172200" y="1417320"/>
+            <a:ext cx="384048" cy="384048"/>
+          </a:xfrm>
+          <a:prstGeom prst="ellipse">
+            <a:avLst/>
+          </a:prstGeom>
+          <a:solidFill>
+            <a:schemeClr val="accent2"/>
+          </a:solidFill>
+          <a:ln/>
+        </p:spPr>
+        <p:txBody>
+          <a:bodyPr wrap="square" lIns="0" tIns="0" rIns="0" bIns="0" rtlCol="0" anchor="ctr"/>
+          <a:lstStyle/>
+          <a:p>
+            <a:pPr algn="ctr" indent="0" marL="0">
+              <a:buNone/>
+            </a:pPr>
+            <a:r>
+              <a:rPr lang="en-US" sz="1400" b="1" dirty="0">
+                <a:solidFill>
+                  <a:schemeClr val="bg1"/>
+                </a:solidFill>
+              </a:rPr>
+              <a:t>3</a:t>
+            </a:r>
+            <a:endParaRPr lang="en-US" sz="1400" dirty="0"/>
+          </a:p>
+        </p:txBody>
+      </p:sp>
+      <p:sp>
+        <p:nvSpPr>
+          <p:cNvPr id="13" name="Text 11"/>
+          <p:cNvSpPr txBox="1"/>
+          <p:nvPr/>
+        </p:nvSpPr>
+        <p:spPr>
+          <a:xfrm>
+            <a:off x="6629400" y="1417320"/>
+            <a:ext cx="1874520" cy="384048"/>
+          </a:xfrm>
+          <a:prstGeom prst="rect">
+            <a:avLst/>
+          </a:prstGeom>
+          <a:noFill/>
+          <a:ln/>
+        </p:spPr>
+        <p:txBody>
+          <a:bodyPr wrap="square" lIns="0" tIns="0" rIns="0" bIns="0" rtlCol="0" anchor="ctr"/>
+          <a:lstStyle/>
+          <a:p>
+            <a:pPr indent="0" marL="0">
+              <a:buNone/>
+            </a:pPr>
+            <a:r>
+              <a:rPr lang="en-US" sz="1600" b="1" dirty="0">
+                <a:solidFill>
+                  <a:schemeClr val="tx2"/>
+                </a:solidFill>
+              </a:rPr>
+              <a:t>High availability</a:t>
+            </a:r>
+            <a:endParaRPr lang="en-US" sz="1600" dirty="0"/>
+          </a:p>
+        </p:txBody>
+      </p:sp>
+      <p:sp>
+        <p:nvSpPr>
+          <p:cNvPr id="14" name="Text 12"/>
+          <p:cNvSpPr txBox="1"/>
+          <p:nvPr/>
+        </p:nvSpPr>
+        <p:spPr>
+          <a:xfrm>
+            <a:off x="6172200" y="1901952"/>
+            <a:ext cx="2286000" cy="868680"/>
+          </a:xfrm>
+          <a:prstGeom prst="rect">
+            <a:avLst/>
+          </a:prstGeom>
+          <a:noFill/>
+          <a:ln/>
+        </p:spPr>
+        <p:txBody>
+          <a:bodyPr wrap="square" lIns="0" tIns="0" rIns="0" bIns="0" rtlCol="0" anchor="t"/>
+          <a:lstStyle/>
+          <a:p>
+            <a:pPr indent="0" marL="0">
+              <a:buNone/>
+            </a:pPr>
+            <a:r>
+              <a:rPr lang="en-US" sz="1400" dirty="0">
+                <a:solidFill>
+                  <a:schemeClr val="tx1"/>
+                </a:solidFill>
+              </a:rPr>
+              <a:t>Load balancer and auto scaling over two zones</a:t>
+            </a:r>
+            <a:endParaRPr lang="en-US" sz="1400" dirty="0"/>
+          </a:p>
+        </p:txBody>
+      </p:sp>
+      <p:sp>
+        <p:nvSpPr>
+          <p:cNvPr id="15" name="rm3"/>
+          <p:cNvSpPr/>
+          <p:nvPr/>
+        </p:nvSpPr>
+        <p:spPr>
+          <a:xfrm>
+            <a:off x="548640" y="3017520"/>
+            <a:ext cx="2560320" cy="1554480"/>
+          </a:xfrm>
+          <a:prstGeom prst="roundRect">
+            <a:avLst>
+              <a:gd name="adj" fmla="val 4706"/>
+            </a:avLst>
+          </a:prstGeom>
+          <a:solidFill>
+            <a:schemeClr val="bg2"/>
+          </a:solidFill>
+          <a:ln w="6350">
+            <a:solidFill>
+              <a:schemeClr val="bg2"/>
+            </a:solidFill>
+            <a:prstDash val="solid"/>
+          </a:ln>
+        </p:spPr>
+      </p:sp>
+      <p:sp>
+        <p:nvSpPr>
+          <p:cNvPr id="16" name="rn3"/>
+          <p:cNvSpPr txBox="1"/>
+          <p:nvPr/>
+        </p:nvSpPr>
+        <p:spPr>
+          <a:xfrm>
+            <a:off x="685800" y="3154680"/>
+            <a:ext cx="384048" cy="384048"/>
+          </a:xfrm>
+          <a:prstGeom prst="ellipse">
+            <a:avLst/>
+          </a:prstGeom>
+          <a:solidFill>
+            <a:schemeClr val="accent2"/>
+          </a:solidFill>
+          <a:ln/>
+        </p:spPr>
+        <p:txBody>
+          <a:bodyPr wrap="square" lIns="0" tIns="0" rIns="0" bIns="0" rtlCol="0" anchor="ctr"/>
+          <a:lstStyle/>
+          <a:p>
+            <a:pPr algn="ctr" indent="0" marL="0">
+              <a:buNone/>
+            </a:pPr>
+            <a:r>
+              <a:rPr lang="en-US" sz="1400" b="1" dirty="0">
+                <a:solidFill>
+                  <a:schemeClr val="bg1"/>
+                </a:solidFill>
+              </a:rPr>
+              <a:t>4</a:t>
+            </a:r>
+            <a:endParaRPr lang="en-US" sz="1400" dirty="0"/>
+          </a:p>
+        </p:txBody>
+      </p:sp>
+      <p:sp>
+        <p:nvSpPr>
+          <p:cNvPr id="17" name="Text 15"/>
+          <p:cNvSpPr txBox="1"/>
+          <p:nvPr/>
+        </p:nvSpPr>
+        <p:spPr>
+          <a:xfrm>
+            <a:off x="1143000" y="3154680"/>
+            <a:ext cx="1874520" cy="384048"/>
+          </a:xfrm>
+          <a:prstGeom prst="rect">
+            <a:avLst/>
+          </a:prstGeom>
+          <a:noFill/>
+          <a:ln/>
+        </p:spPr>
+        <p:txBody>
+          <a:bodyPr wrap="square" lIns="0" tIns="0" rIns="0" bIns="0" rtlCol="0" anchor="ctr"/>
+          <a:lstStyle/>
+          <a:p>
+            <a:pPr indent="0" marL="0">
+              <a:buNone/>
+            </a:pPr>
+            <a:r>
+              <a:rPr lang="en-US" sz="1600" b="1" dirty="0">
+                <a:solidFill>
+                  <a:schemeClr val="tx2"/>
+                </a:solidFill>
+              </a:rPr>
+              <a:t>Logs</a:t>
+            </a:r>
+            <a:endParaRPr lang="en-US" sz="1600" dirty="0"/>
+          </a:p>
+        </p:txBody>
+      </p:sp>
+      <p:sp>
+        <p:nvSpPr>
+          <p:cNvPr id="18" name="Text 16"/>
+          <p:cNvSpPr txBox="1"/>
+          <p:nvPr/>
+        </p:nvSpPr>
+        <p:spPr>
+          <a:xfrm>
+            <a:off x="685800" y="3639312"/>
+            <a:ext cx="2286000" cy="868680"/>
+          </a:xfrm>
+          <a:prstGeom prst="rect">
+            <a:avLst/>
+          </a:prstGeom>
+          <a:noFill/>
+          <a:ln/>
+        </p:spPr>
+        <p:txBody>
+          <a:bodyPr wrap="square" lIns="0" tIns="0" rIns="0" bIns="0" rtlCol="0" anchor="t"/>
+          <a:lstStyle/>
+          <a:p>
+            <a:pPr indent="0" marL="0">
+              <a:buNone/>
+            </a:pPr>
+            <a:r>
+              <a:rPr lang="en-US" sz="1400" dirty="0">
+                <a:solidFill>
+                  <a:schemeClr val="tx1"/>
+                </a:solidFill>
+              </a:rPr>
+              <a:t>CloudWatch agent for nginx and API logs</a:t>
+            </a:r>
+            <a:endParaRPr lang="en-US" sz="1400" dirty="0"/>
+          </a:p>
+        </p:txBody>
+      </p:sp>
+      <p:sp>
+        <p:nvSpPr>
+          <p:cNvPr id="19" name="rm4"/>
+          <p:cNvSpPr/>
+          <p:nvPr/>
+        </p:nvSpPr>
+        <p:spPr>
+          <a:xfrm>
+            <a:off x="3291840" y="3017520"/>
+            <a:ext cx="2560320" cy="1554480"/>
+          </a:xfrm>
+          <a:prstGeom prst="roundRect">
+            <a:avLst>
+              <a:gd name="adj" fmla="val 4706"/>
+            </a:avLst>
+          </a:prstGeom>
+          <a:solidFill>
+            <a:schemeClr val="bg2"/>
+          </a:solidFill>
+          <a:ln w="6350">
+            <a:solidFill>
+              <a:schemeClr val="bg2"/>
+            </a:solidFill>
+            <a:prstDash val="solid"/>
+          </a:ln>
+        </p:spPr>
+      </p:sp>
+      <p:sp>
+        <p:nvSpPr>
+          <p:cNvPr id="20" name="rn4"/>
+          <p:cNvSpPr txBox="1"/>
+          <p:nvPr/>
+        </p:nvSpPr>
+        <p:spPr>
+          <a:xfrm>
+            <a:off x="3429000" y="3154680"/>
+            <a:ext cx="384048" cy="384048"/>
+          </a:xfrm>
+          <a:prstGeom prst="ellipse">
+            <a:avLst/>
+          </a:prstGeom>
+          <a:solidFill>
+            <a:schemeClr val="accent2"/>
+          </a:solidFill>
+          <a:ln/>
+        </p:spPr>
+        <p:txBody>
+          <a:bodyPr wrap="square" lIns="0" tIns="0" rIns="0" bIns="0" rtlCol="0" anchor="ctr"/>
+          <a:lstStyle/>
+          <a:p>
+            <a:pPr algn="ctr" indent="0" marL="0">
+              <a:buNone/>
+            </a:pPr>
+            <a:r>
+              <a:rPr lang="en-US" sz="1400" b="1" dirty="0">
+                <a:solidFill>
+                  <a:schemeClr val="bg1"/>
+                </a:solidFill>
+              </a:rPr>
+              <a:t>5</a:t>
+            </a:r>
+            <a:endParaRPr lang="en-US" sz="1400" dirty="0"/>
+          </a:p>
+        </p:txBody>
+      </p:sp>
+      <p:sp>
+        <p:nvSpPr>
+          <p:cNvPr id="21" name="Text 19"/>
+          <p:cNvSpPr txBox="1"/>
+          <p:nvPr/>
+        </p:nvSpPr>
+        <p:spPr>
+          <a:xfrm>
+            <a:off x="3886200" y="3154680"/>
+            <a:ext cx="1874520" cy="384048"/>
+          </a:xfrm>
+          <a:prstGeom prst="rect">
+            <a:avLst/>
+          </a:prstGeom>
+          <a:noFill/>
+          <a:ln/>
+        </p:spPr>
+        <p:txBody>
+          <a:bodyPr wrap="square" lIns="0" tIns="0" rIns="0" bIns="0" rtlCol="0" anchor="ctr"/>
+          <a:lstStyle/>
+          <a:p>
+            <a:pPr indent="0" marL="0">
+              <a:buNone/>
+            </a:pPr>
+            <a:r>
+              <a:rPr lang="en-US" sz="1600" b="1" dirty="0">
+                <a:solidFill>
+                  <a:schemeClr val="tx2"/>
+                </a:solidFill>
+              </a:rPr>
+              <a:t>Backups</a:t>
+            </a:r>
+            <a:endParaRPr lang="en-US" sz="1600" dirty="0"/>
+          </a:p>
+        </p:txBody>
+      </p:sp>
+      <p:sp>
+        <p:nvSpPr>
+          <p:cNvPr id="22" name="Text 20"/>
+          <p:cNvSpPr txBox="1"/>
+          <p:nvPr/>
+        </p:nvSpPr>
+        <p:spPr>
+          <a:xfrm>
+            <a:off x="3429000" y="3639312"/>
+            <a:ext cx="2286000" cy="868680"/>
+          </a:xfrm>
+          <a:prstGeom prst="rect">
+            <a:avLst/>
+          </a:prstGeom>
+          <a:noFill/>
+          <a:ln/>
+        </p:spPr>
+        <p:txBody>
+          <a:bodyPr wrap="square" lIns="0" tIns="0" rIns="0" bIns="0" rtlCol="0" anchor="t"/>
+          <a:lstStyle/>
+          <a:p>
+            <a:pPr indent="0" marL="0">
+              <a:buNone/>
+            </a:pPr>
+            <a:r>
+              <a:rPr lang="en-US" sz="1400" dirty="0">
+                <a:solidFill>
+                  <a:schemeClr val="tx1"/>
+                </a:solidFill>
+              </a:rPr>
+              <a:t>Encrypted volume and AWS Backup snapshots</a:t>
+            </a:r>
+            <a:endParaRPr lang="en-US" sz="1400" dirty="0"/>
+          </a:p>
+        </p:txBody>
+      </p:sp>
+      <p:sp>
+        <p:nvSpPr>
+          <p:cNvPr id="23" name="rm5"/>
+          <p:cNvSpPr/>
+          <p:nvPr/>
+        </p:nvSpPr>
+        <p:spPr>
+          <a:xfrm>
+            <a:off x="6035040" y="3017520"/>
+            <a:ext cx="2560320" cy="1554480"/>
+          </a:xfrm>
+          <a:prstGeom prst="roundRect">
+            <a:avLst>
+              <a:gd name="adj" fmla="val 4706"/>
+            </a:avLst>
+          </a:prstGeom>
+          <a:solidFill>
+            <a:schemeClr val="bg2"/>
+          </a:solidFill>
+          <a:ln w="6350">
+            <a:solidFill>
+              <a:schemeClr val="bg2"/>
+            </a:solidFill>
+            <a:prstDash val="solid"/>
+          </a:ln>
+        </p:spPr>
+      </p:sp>
+      <p:sp>
+        <p:nvSpPr>
+          <p:cNvPr id="24" name="rn5"/>
+          <p:cNvSpPr txBox="1"/>
+          <p:nvPr/>
+        </p:nvSpPr>
+        <p:spPr>
+          <a:xfrm>
+            <a:off x="6172200" y="3154680"/>
+            <a:ext cx="384048" cy="384048"/>
+          </a:xfrm>
+          <a:prstGeom prst="ellipse">
+            <a:avLst/>
+          </a:prstGeom>
+          <a:solidFill>
+            <a:schemeClr val="accent2"/>
+          </a:solidFill>
+          <a:ln/>
+        </p:spPr>
+        <p:txBody>
+          <a:bodyPr wrap="square" lIns="0" tIns="0" rIns="0" bIns="0" rtlCol="0" anchor="ctr"/>
+          <a:lstStyle/>
+          <a:p>
+            <a:pPr algn="ctr" indent="0" marL="0">
+              <a:buNone/>
+            </a:pPr>
+            <a:r>
+              <a:rPr lang="en-US" sz="1400" b="1" dirty="0">
+                <a:solidFill>
+                  <a:schemeClr val="bg1"/>
+                </a:solidFill>
+              </a:rPr>
+              <a:t>6</a:t>
+            </a:r>
+            <a:endParaRPr lang="en-US" sz="1400" dirty="0"/>
+          </a:p>
+        </p:txBody>
+      </p:sp>
+      <p:sp>
+        <p:nvSpPr>
+          <p:cNvPr id="25" name="Text 23"/>
+          <p:cNvSpPr txBox="1"/>
+          <p:nvPr/>
+        </p:nvSpPr>
+        <p:spPr>
+          <a:xfrm>
+            <a:off x="6629400" y="3154680"/>
+            <a:ext cx="1874520" cy="384048"/>
+          </a:xfrm>
+          <a:prstGeom prst="rect">
+            <a:avLst/>
+          </a:prstGeom>
+          <a:noFill/>
+          <a:ln/>
+        </p:spPr>
+        <p:txBody>
+          <a:bodyPr wrap="square" lIns="0" tIns="0" rIns="0" bIns="0" rtlCol="0" anchor="ctr"/>
+          <a:lstStyle/>
+          <a:p>
+            <a:pPr indent="0" marL="0">
+              <a:buNone/>
+            </a:pPr>
+            <a:r>
+              <a:rPr lang="en-US" sz="1600" b="1" dirty="0">
+                <a:solidFill>
+                  <a:schemeClr val="tx2"/>
+                </a:solidFill>
+              </a:rPr>
+              <a:t>CI/CD</a:t>
+            </a:r>
+            <a:endParaRPr lang="en-US" sz="1600" dirty="0"/>
+          </a:p>
+        </p:txBody>
+      </p:sp>
+      <p:sp>
+        <p:nvSpPr>
+          <p:cNvPr id="26" name="Text 24"/>
+          <p:cNvSpPr txBox="1"/>
+          <p:nvPr/>
+        </p:nvSpPr>
+        <p:spPr>
+          <a:xfrm>
+            <a:off x="6172200" y="3639312"/>
+            <a:ext cx="2286000" cy="868680"/>
+          </a:xfrm>
+          <a:prstGeom prst="rect">
+            <a:avLst/>
+          </a:prstGeom>
+          <a:noFill/>
+          <a:ln/>
+        </p:spPr>
+        <p:txBody>
+          <a:bodyPr wrap="square" lIns="0" tIns="0" rIns="0" bIns="0" rtlCol="0" anchor="t"/>
+          <a:lstStyle/>
+          <a:p>
+            <a:pPr indent="0" marL="0">
+              <a:buNone/>
+            </a:pPr>
+            <a:r>
+              <a:rPr lang="en-US" sz="1400" dirty="0">
+                <a:solidFill>
+                  <a:schemeClr val="tx1"/>
+                </a:solidFill>
+              </a:rPr>
+              <a:t>GitHub Actions updates the stack on push</a:t>
+            </a:r>
+            <a:endParaRPr lang="en-US" sz="1400" dirty="0"/>
+          </a:p>
+        </p:txBody>
+      </p:sp>
+      <p:sp>
+        <p:nvSpPr>
+          <p:cNvPr id="25" name="Slide Number Placeholder 0"/>
+          <p:cNvSpPr>
+            <a:spLocks noGrp="1"/>
+          </p:cNvSpPr>
+          <p:nvPr>
+            <p:ph type="sldNum" sz="quarter" idx="4294967295"/>
+          </p:nvPr>
+        </p:nvSpPr>
+        <p:spPr>
+          <a:xfrm>
+            <a:off x="8229600" y="4754880"/>
+            <a:ext cx="548640" cy="274320"/>
+          </a:xfrm>
+          <a:prstGeom prst="rect">
+            <a:avLst/>
+          </a:prstGeom>
+          <a:extLst>
+            <a:ext uri="{C572A759-6A51-4108-AA02-DFA0A04FC94B}">
+              <ma14:wrappingTextBoxFlag xmlns:ma14="http://schemas.microsoft.com/office/mac/drawingml/2011/main" val="0"/>
+            </a:ext>
+          </a:extLst>
+        </p:spPr>
+        <p:txBody>
+          <a:bodyPr/>
+          <a:lstStyle>
+            <a:lvl1pPr>
+              <a:defRPr sz="1000">
+                <a:solidFill>
+                  <a:srgbClr val="6B7C8F"/>
+                </a:solidFill>
+              </a:defRPr>
+            </a:lvl1pPr>
+          </a:lstStyle>
+          <a:p>
+            <a:pPr algn="l"/>
+            <a:fld id="{F7021451-1387-4CA6-816F-3879F97B5CBC}" type="slidenum">
+              <a:rPr b="0" lang="en-US"/>
+              <a:t>11</a:t>
+            </a:fld>
+            <a:endParaRPr lang="en-US"/>
+          </a:p>
+        </p:txBody>
+      </p:sp>
+    </p:spTree>
+  </p:cSld>
+  <p:clrMapOvr>
+    <a:masterClrMapping/>
+  </p:clrMapOvr>
+</p:sld>
+</file>
+
+<file path=ppt/slides/slide12.xml><?xml version="1.0" encoding="utf-8"?>
+<p:sld xmlns:a="http://schemas.openxmlformats.org/drawingml/2006/main" xmlns:r="http://schemas.openxmlformats.org/officeDocument/2006/relationships" xmlns:p="http://schemas.openxmlformats.org/presentationml/2006/main">
+  <p:cSld name="Slide 12">
     <p:spTree>
       <p:nvGrpSpPr>
         <p:cNvPr id="1" name=""/>
@@ -8127,7 +9223,7 @@
                   <a:schemeClr val="accent6"/>
                 </a:solidFill>
               </a:rPr>
-              <a:t>Atlas connection timing out</a:t>
+              <a:t>Login timed out, DB looked blocked</a:t>
             </a:r>
             <a:endParaRPr lang="en-US" sz="1500" dirty="0"/>
           </a:p>
@@ -8163,7 +9259,7 @@
                   <a:schemeClr val="tx1"/>
                 </a:solidFill>
               </a:rPr>
-              <a:t>Allowlist the Elastic IP and make sure the cluster is running</a:t>
+              <a:t>Shell dropped the &amp; characters in the connection string; fixed with printf %q</a:t>
             </a:r>
             <a:endParaRPr lang="en-US" sz="1400" dirty="0"/>
           </a:p>

</xml_diff>